<commit_message>
talk: operating-mode framing + coflow JCT slide
</commit_message>
<xml_diff>
--- a/examples/hpcc/hpcc-fs/talk/ipccc2026-talk.pptx
+++ b/examples/hpcc/hpcc-fs/talk/ipccc2026-talk.pptx
@@ -23,9 +23,10 @@
     <p:sldId id="271" r:id="rId17"/>
     <p:sldId id="272" r:id="rId18"/>
     <p:sldId id="273" r:id="rId19"/>
+    <p:sldId id="274" r:id="rId20"/>
   </p:sldIdLst>
   <p:notesMasterIdLst>
-    <p:notesMasterId r:id="rId20"/>
+    <p:notesMasterId r:id="rId21"/>
   </p:notesMasterIdLst>
   <p:sldSz cx="9144000" cy="5143500"/>
   <p:notesSz cx="5143500" cy="9144000"/>
@@ -724,6 +725,375 @@
 </c:chartSpace>
 </file>
 
+<file path=ppt/charts/chart3.xml><?xml version="1.0" encoding="utf-8"?>
+<c:chartSpace xmlns:c="http://schemas.openxmlformats.org/drawingml/2006/chart" xmlns:a="http://schemas.openxmlformats.org/drawingml/2006/main" xmlns:r="http://schemas.openxmlformats.org/officeDocument/2006/relationships">
+  <c:date1904 val="0"/>
+  <c:roundedCorners val="1"/>
+  <c:chart>
+    <c:autoTitleDeleted val="1"/>
+    <c:plotArea>
+      <c:layout/>
+      <c:barChart>
+        <c:barDir val="col"/>
+        <c:grouping val="clustered"/>
+        <c:varyColors val="0"/>
+        <c:ser>
+          <c:idx val="0"/>
+          <c:order val="0"/>
+          <c:tx>
+            <c:strRef>
+              <c:f>Sheet1!$B$1</c:f>
+              <c:strCache>
+                <c:ptCount val="1"/>
+                <c:pt idx="0">
+                  <c:v>stock HPCC</c:v>
+                </c:pt>
+              </c:strCache>
+            </c:strRef>
+          </c:tx>
+          <c:spPr>
+            <a:solidFill>
+              <a:srgbClr val="C0504D"/>
+            </a:solidFill>
+            <a:effectLst/>
+          </c:spPr>
+          <c:invertIfNegative val="0"/>
+          <c:dLbls>
+            <c:numFmt formatCode="#,##0" sourceLinked="0"/>
+            <c:txPr>
+              <a:bodyPr/>
+              <a:lstStyle/>
+              <a:p>
+                <a:pPr>
+                  <a:defRPr b="0" i="0" strike="noStrike" sz="1200" u="none">
+                    <a:solidFill>
+                      <a:srgbClr val="000000"/>
+                    </a:solidFill>
+                    <a:latin typeface="Arial"/>
+                  </a:defRPr>
+                </a:pPr>
+              </a:p>
+            </c:txPr>
+            <c:showLegendKey val="0"/>
+            <c:showVal val="0"/>
+            <c:showCatName val="0"/>
+            <c:showSerName val="0"/>
+            <c:showPercent val="0"/>
+            <c:showBubbleSize val="0"/>
+            <c:showLeaderLines val="0"/>
+          </c:dLbls>
+          <c:cat>
+            <c:multiLvlStrRef>
+              <c:f>Sheet1!$A$2:$A$6</c:f>
+              <c:multiLvlStrCache>
+                <c:ptCount val="5"/>
+                <c:lvl>
+                  <c:pt idx="0">
+                    <c:v>seed 0</c:v>
+                  </c:pt>
+                  <c:pt idx="1">
+                    <c:v>seed 101</c:v>
+                  </c:pt>
+                  <c:pt idx="2">
+                    <c:v>seed 202</c:v>
+                  </c:pt>
+                  <c:pt idx="3">
+                    <c:v>seed 303</c:v>
+                  </c:pt>
+                  <c:pt idx="4">
+                    <c:v>seed 404</c:v>
+                  </c:pt>
+                </c:lvl>
+              </c:multiLvlStrCache>
+            </c:multiLvlStrRef>
+          </c:cat>
+          <c:val>
+            <c:numRef>
+              <c:f>Sheet1!$B$2:$B$6</c:f>
+              <c:numCache>
+                <c:formatCode>General</c:formatCode>
+                <c:ptCount val="5"/>
+                <c:pt idx="0">
+                  <c:v>23.27</c:v>
+                </c:pt>
+                <c:pt idx="1">
+                  <c:v>22.44</c:v>
+                </c:pt>
+                <c:pt idx="2">
+                  <c:v>23.22</c:v>
+                </c:pt>
+                <c:pt idx="3">
+                  <c:v>22.33</c:v>
+                </c:pt>
+                <c:pt idx="4">
+                  <c:v>23.11</c:v>
+                </c:pt>
+              </c:numCache>
+            </c:numRef>
+          </c:val>
+        </c:ser>
+        <c:ser>
+          <c:idx val="1"/>
+          <c:order val="1"/>
+          <c:tx>
+            <c:strRef>
+              <c:f>Sheet1!$C$1</c:f>
+              <c:strCache>
+                <c:ptCount val="1"/>
+                <c:pt idx="0">
+                  <c:v>HPCC-FS</c:v>
+                </c:pt>
+              </c:strCache>
+            </c:strRef>
+          </c:tx>
+          <c:spPr>
+            <a:solidFill>
+              <a:srgbClr val="4F81BD"/>
+            </a:solidFill>
+            <a:effectLst/>
+          </c:spPr>
+          <c:invertIfNegative val="0"/>
+          <c:dLbls>
+            <c:numFmt formatCode="#,##0" sourceLinked="0"/>
+            <c:txPr>
+              <a:bodyPr/>
+              <a:lstStyle/>
+              <a:p>
+                <a:pPr>
+                  <a:defRPr b="0" i="0" strike="noStrike" sz="1200" u="none">
+                    <a:solidFill>
+                      <a:srgbClr val="000000"/>
+                    </a:solidFill>
+                    <a:latin typeface="Arial"/>
+                  </a:defRPr>
+                </a:pPr>
+              </a:p>
+            </c:txPr>
+            <c:showLegendKey val="0"/>
+            <c:showVal val="0"/>
+            <c:showCatName val="0"/>
+            <c:showSerName val="0"/>
+            <c:showPercent val="0"/>
+            <c:showBubbleSize val="0"/>
+            <c:showLeaderLines val="0"/>
+          </c:dLbls>
+          <c:cat>
+            <c:multiLvlStrRef>
+              <c:f>Sheet1!$A$2:$A$6</c:f>
+              <c:multiLvlStrCache>
+                <c:ptCount val="5"/>
+                <c:lvl>
+                  <c:pt idx="0">
+                    <c:v>seed 0</c:v>
+                  </c:pt>
+                  <c:pt idx="1">
+                    <c:v>seed 101</c:v>
+                  </c:pt>
+                  <c:pt idx="2">
+                    <c:v>seed 202</c:v>
+                  </c:pt>
+                  <c:pt idx="3">
+                    <c:v>seed 303</c:v>
+                  </c:pt>
+                  <c:pt idx="4">
+                    <c:v>seed 404</c:v>
+                  </c:pt>
+                </c:lvl>
+              </c:multiLvlStrCache>
+            </c:multiLvlStrRef>
+          </c:cat>
+          <c:val>
+            <c:numRef>
+              <c:f>Sheet1!$C$2:$C$6</c:f>
+              <c:numCache>
+                <c:formatCode>General</c:formatCode>
+                <c:ptCount val="5"/>
+                <c:pt idx="0">
+                  <c:v>17.99</c:v>
+                </c:pt>
+                <c:pt idx="1">
+                  <c:v>17.96</c:v>
+                </c:pt>
+                <c:pt idx="2">
+                  <c:v>17.99</c:v>
+                </c:pt>
+                <c:pt idx="3">
+                  <c:v>17.97</c:v>
+                </c:pt>
+                <c:pt idx="4">
+                  <c:v>17.92</c:v>
+                </c:pt>
+              </c:numCache>
+            </c:numRef>
+          </c:val>
+        </c:ser>
+        <c:dLbls>
+          <c:numFmt formatCode="#,##0" sourceLinked="0"/>
+          <c:txPr>
+            <a:bodyPr/>
+            <a:lstStyle/>
+            <a:p>
+              <a:pPr>
+                <a:defRPr b="0" i="0" strike="noStrike" sz="1200" u="none">
+                  <a:solidFill>
+                    <a:srgbClr val="000000"/>
+                  </a:solidFill>
+                  <a:latin typeface="Arial"/>
+                </a:defRPr>
+              </a:pPr>
+            </a:p>
+          </c:txPr>
+          <c:showLegendKey val="0"/>
+          <c:showVal val="0"/>
+          <c:showCatName val="0"/>
+          <c:showSerName val="0"/>
+          <c:showPercent val="0"/>
+          <c:showBubbleSize val="0"/>
+          <c:showLeaderLines val="0"/>
+        </c:dLbls>
+        <c:gapWidth val="150"/>
+        <c:overlap val="0"/>
+        <c:axId val="2094734554"/>
+        <c:axId val="2094734552"/>
+        <c:axId val="2094734556"/>
+      </c:barChart>
+      <c:catAx>
+        <c:axId val="2094734554"/>
+        <c:scaling>
+          <c:orientation val="minMax"/>
+        </c:scaling>
+        <c:delete val="0"/>
+        <c:axPos val="b"/>
+        <c:numFmt formatCode="General" sourceLinked="1"/>
+        <c:majorTickMark val="out"/>
+        <c:minorTickMark val="none"/>
+        <c:tickLblPos val="low"/>
+        <c:spPr>
+          <a:ln w="12700" cap="flat">
+            <a:solidFill>
+              <a:srgbClr val="888888"/>
+            </a:solidFill>
+            <a:prstDash val="solid"/>
+            <a:round/>
+          </a:ln>
+        </c:spPr>
+        <c:txPr>
+          <a:bodyPr/>
+          <a:lstStyle/>
+          <a:p>
+            <a:pPr>
+              <a:defRPr sz="1200" b="0" i="0" u="none" strike="noStrike">
+                <a:solidFill>
+                  <a:srgbClr val="5B6675"/>
+                </a:solidFill>
+                <a:latin typeface="Arial"/>
+              </a:defRPr>
+            </a:pPr>
+            <a:endParaRPr lang="en-US"/>
+          </a:p>
+        </c:txPr>
+        <c:crossAx val="2094734552"/>
+        <c:crosses val="autoZero"/>
+        <c:auto val="1"/>
+        <c:lblAlgn val="ctr"/>
+        <c:noMultiLvlLbl val="1"/>
+      </c:catAx>
+      <c:valAx>
+        <c:axId val="2094734552"/>
+        <c:scaling>
+          <c:orientation val="minMax"/>
+          <c:max val="26"/>
+          <c:min val="0"/>
+        </c:scaling>
+        <c:delete val="0"/>
+        <c:axPos val="l"/>
+        <c:majorGridlines>
+          <c:spPr>
+            <a:ln w="6350" cap="flat">
+              <a:solidFill>
+                <a:srgbClr val="E4E9F0"/>
+              </a:solidFill>
+              <a:prstDash val="solid"/>
+              <a:round/>
+            </a:ln>
+          </c:spPr>
+        </c:majorGridlines>
+        <c:numFmt formatCode="General" sourceLinked="0"/>
+        <c:majorTickMark val="out"/>
+        <c:minorTickMark val="none"/>
+        <c:tickLblPos val="nextTo"/>
+        <c:spPr>
+          <a:ln w="12700" cap="flat">
+            <a:solidFill>
+              <a:srgbClr val="888888"/>
+            </a:solidFill>
+            <a:prstDash val="solid"/>
+            <a:round/>
+          </a:ln>
+        </c:spPr>
+        <c:txPr>
+          <a:bodyPr/>
+          <a:lstStyle/>
+          <a:p>
+            <a:pPr>
+              <a:defRPr sz="1200" b="0" i="0" u="none" strike="noStrike">
+                <a:solidFill>
+                  <a:srgbClr val="5B6675"/>
+                </a:solidFill>
+                <a:latin typeface="Arial"/>
+              </a:defRPr>
+            </a:pPr>
+            <a:endParaRPr lang="en-US"/>
+          </a:p>
+        </c:txPr>
+        <c:crossAx val="2094734554"/>
+        <c:crosses val="autoZero"/>
+        <c:crossBetween val="between"/>
+      </c:valAx>
+      <c:spPr>
+        <a:noFill/>
+        <a:ln>
+          <a:noFill/>
+        </a:ln>
+        <a:effectLst/>
+      </c:spPr>
+    </c:plotArea>
+    <c:legend>
+      <c:legendPos val="b"/>
+      <c:overlay val="0"/>
+      <c:txPr>
+        <a:bodyPr/>
+        <a:lstStyle/>
+        <a:p>
+          <a:pPr>
+            <a:defRPr>
+              <a:solidFill>
+                <a:srgbClr val="5B6675"/>
+              </a:solidFill>
+            </a:defRPr>
+          </a:pPr>
+          <a:endParaRPr lang="en-US"/>
+        </a:p>
+      </c:txPr>
+    </c:legend>
+    <c:plotVisOnly val="1"/>
+    <c:dispBlanksAs val="span"/>
+  </c:chart>
+  <c:spPr>
+    <a:solidFill>
+      <a:srgbClr val="FFFFFF"/>
+    </a:solidFill>
+    <a:ln>
+      <a:noFill/>
+    </a:ln>
+    <a:effectLst/>
+  </c:spPr>
+  <c:externalData r:id="rId1">
+    <c:autoUpdate val="0"/>
+  </c:externalData>
+</c:chartSpace>
+</file>
+
 <file path=ppt/notesMasters/notesMaster1.xml><?xml version="1.0" encoding="utf-8"?>
 <p:notesMaster xmlns:a="http://schemas.openxmlformats.org/drawingml/2006/main" xmlns:r="http://schemas.openxmlformats.org/officeDocument/2006/relationships" xmlns:p="http://schemas.openxmlformats.org/presentationml/2006/main">
   <p:cSld>
@@ -1119,7 +1489,7 @@
           <a:p>
             <a:r>
               <a:rPr lang="en-US" dirty="0"/>
-              <a:t>Thank you. This talk is about a fairness blind spot in HPCC — the SIGCOMM'19 INT-based congestion control — and a deliberately minimal switch-side fix. The one-line story: a flow crossing several bottlenecks gets half its fair share, no sender-side fix we tried can repair it, and one fair-rate scalar per switch port repairs it completely.</a:t>
+              <a:t>Thank you. This talk is about a fairness blind spot in HPCC — the SIGCOMM'19 INT-based congestion control — and a deliberately minimal switch-side alternative: an operating mode that coexists with stock HPCC on the same fabric. The one-line story: a flow crossing several bottlenecks gets half its fair share, no sender-side correction we tried can close the gap, and one fair-rate scalar per switch port — offered as a per-class mode, not a replacement — closes it completely.</a:t>
             </a:r>
             <a:endParaRPr lang="en-US" dirty="0"/>
           </a:p>
@@ -1559,7 +1929,7 @@
           <a:p>
             <a:r>
               <a:rPr lang="en-US" dirty="0"/>
-              <a:t>Three defensibility checks. One: disabling the window is necessary, not a convenience — put it back and the penalty returns, growing with path length, because HPCC's window is sized for the NIC, not the path. Two: we did not tune RCP — the textbook defaults, and one-at-a-time sweeps barely move the result. Three: the cost question — on HPCC's home turf, a single-bottleneck incast, a moderate startup rate makes HPCC-FS match or beat HPCC's FCT while holding a quarter of the queue. On what we measured, the fairness fix is not a trade-off.</a:t>
+              <a:t>So what does fairness buy on a workload operators care about? Collective communication: an allreduce step finishes when its slowest flow finishes, and the slowest flows are exactly the cross-pod multi-bottleneck ones stock HPCC starves. A 16-flow ring allreduce across five ECMP hash seeds: HPCC-FS cuts job completion time about 21 percent at every seed, and makes it placement-invariant. And a nuance we like being honest about: in this mix the short background flows also got three times faster — under winner-take-all, whether a short flow wins or loses is a placement lottery; max-min removes the lottery.</a:t>
             </a:r>
             <a:endParaRPr lang="en-US" dirty="0"/>
           </a:p>
@@ -1647,7 +2017,7 @@
           <a:p>
             <a:r>
               <a:rPr lang="en-US" dirty="0"/>
-              <a:t>We are deliberately explicit about scope. The mechanism is RCP — our contribution is showing where the fix has to live and that placing it there is cheap. The evaluation is simulation-only; we re-ported the HPCC simulator onto modern ns-3 and verified it reproduces the original paper's baselines before building on it. Convergence is milliseconds, not one round trip. And the natural next step is a hybrid that keeps HPCC's per-flow precision under a fair-rate ceiling — the obstacle is HPCC's NIC-sized window, which is its own interesting problem.</a:t>
+              <a:t>Three defensibility checks. One: disabling the window is necessary, not a convenience — put it back and the penalty returns, growing with path length, because HPCC's window is sized for the NIC, not the path. Two: we did not tune RCP — the textbook defaults, and one-at-a-time sweeps barely move the result. Three: the cost question — on HPCC's home turf, a single-bottleneck incast, a moderate startup rate makes HPCC-FS match or beat HPCC's FCT while holding a quarter of the queue. On what we measured, the fairness fix is not a trade-off.</a:t>
             </a:r>
             <a:endParaRPr lang="en-US" dirty="0"/>
           </a:p>
@@ -1735,7 +2105,7 @@
           <a:p>
             <a:r>
               <a:rPr lang="en-US" dirty="0"/>
-              <a:t>To close: a real, robust fairness failure in the state of the art; evidence that the endpoint can't fix it because the endpoint can't see the flow count; and a deliberately minimal switch fix — one field, one scalar — that lands within half a percent of the max-min oracle with zero PFC, leaving stock HPCC byte-for-byte intact. Everything is in the artifact, including a full reproduction of the original HPCC baselines. Happy to take questions.</a:t>
+              <a:t>We are deliberately explicit about scope. The mechanism is RCP — our contribution is showing where the fix has to live and that placing it there is cheap. The evaluation is simulation-only; we re-ported the HPCC simulator onto modern ns-3 and verified it reproduces the original paper's baselines before building on it. Convergence is milliseconds, not one round trip. And the natural next step is a hybrid that keeps HPCC's per-flow precision under a fair-rate ceiling — the obstacle is HPCC's NIC-sized window, which is its own interesting problem.</a:t>
             </a:r>
             <a:endParaRPr lang="en-US" dirty="0"/>
           </a:p>
@@ -1823,7 +2193,7 @@
           <a:p>
             <a:r>
               <a:rPr lang="en-US" dirty="0"/>
-              <a:t>Backup: if asked whether our refactored simulator is faithful — we ran the original paper's full comparison matrix, 30 configurations, and every qualitative signature reproduces. The raw per-run configs and results are publicly archived and linked from the artifact.</a:t>
+              <a:t>To close: a real, robust fairness failure in the state of the art; evidence that the endpoint can't fix it because the endpoint can't see the flow count; and a deliberately minimal switch fix — one field, one scalar — that lands within half a percent of the max-min oracle with zero PFC, leaving stock HPCC byte-for-byte intact. Everything is in the artifact, including a full reproduction of the original HPCC baselines. Happy to take questions.</a:t>
             </a:r>
             <a:endParaRPr lang="en-US" dirty="0"/>
           </a:p>
@@ -1911,7 +2281,7 @@
           <a:p>
             <a:r>
               <a:rPr lang="en-US" dirty="0"/>
-              <a:t>Two common questions. Mixed sizes: yes, short flows lose some of the headroom they were borrowing from the starved long flow — that's what fairness means; policy beyond max-min is future work. And the odd N&gt;=5 numbers for stock HPCC are an artifact: the INT record physically overflows at 5 hops, so the controller is reading garbage — that's a bug surface our single-field format simply doesn't have.</a:t>
+              <a:t>Backup: if asked whether our refactored simulator is faithful — we ran the original paper's full comparison matrix, 30 configurations, and every qualitative signature reproduces. The raw per-run configs and results are publicly archived and linked from the artifact.</a:t>
             </a:r>
             <a:endParaRPr lang="en-US" dirty="0"/>
           </a:p>
@@ -1935,6 +2305,94 @@
             <a:fld id="{F7021451-1387-4CA6-816F-3879F97B5CBC}" type="slidenum">
               <a:rPr lang="en-US"/>
               <a:t>18</a:t>
+            </a:fld>
+            <a:endParaRPr lang="en-US"/>
+          </a:p>
+        </p:txBody>
+      </p:sp>
+    </p:spTree>
+    <p:extLst>
+      <p:ext uri="{BB962C8B-B14F-4D97-AF65-F5344CB8AC3E}">
+        <p14:creationId xmlns:p14="http://schemas.microsoft.com/office/powerpoint/2010/main" val="1024086991"/>
+      </p:ext>
+    </p:extLst>
+  </p:cSld>
+  <p:clrMapOvr>
+    <a:masterClrMapping/>
+  </p:clrMapOvr>
+</p:notes>
+</file>
+
+<file path=ppt/notesSlides/notesSlide19.xml><?xml version="1.0" encoding="utf-8"?>
+<p:notes xmlns:a="http://schemas.openxmlformats.org/drawingml/2006/main" xmlns:r="http://schemas.openxmlformats.org/officeDocument/2006/relationships" xmlns:p="http://schemas.openxmlformats.org/presentationml/2006/main">
+  <p:cSld>
+    <p:spTree>
+      <p:nvGrpSpPr>
+        <p:cNvPr id="1" name=""/>
+        <p:cNvGrpSpPr/>
+        <p:nvPr/>
+      </p:nvGrpSpPr>
+      <p:grpSpPr>
+        <a:xfrm>
+          <a:off x="0" y="0"/>
+          <a:ext cx="0" cy="0"/>
+          <a:chOff x="0" y="0"/>
+          <a:chExt cx="0" cy="0"/>
+        </a:xfrm>
+      </p:grpSpPr>
+      <p:sp>
+        <p:nvSpPr>
+          <p:cNvPr id="2" name="Slide Image Placeholder 1"/>
+          <p:cNvSpPr>
+            <a:spLocks noGrp="1" noRot="1" noChangeAspect="1"/>
+          </p:cNvSpPr>
+          <p:nvPr>
+            <p:ph type="sldImg"/>
+          </p:nvPr>
+        </p:nvSpPr>
+        <p:spPr/>
+      </p:sp>
+      <p:sp>
+        <p:nvSpPr>
+          <p:cNvPr id="3" name="Notes Placeholder 2"/>
+          <p:cNvSpPr>
+            <a:spLocks noGrp="1"/>
+          </p:cNvSpPr>
+          <p:nvPr>
+            <p:ph type="body" idx="1"/>
+          </p:nvPr>
+        </p:nvSpPr>
+        <p:spPr/>
+        <p:txBody>
+          <a:bodyPr/>
+          <a:lstStyle/>
+          <a:p>
+            <a:r>
+              <a:rPr lang="en-US" dirty="0"/>
+              <a:t>Two common questions. Mixed sizes: yes, short flows lose some of the headroom they were borrowing from the starved long flow — that's what fairness means; policy beyond max-min is future work. And the odd N&gt;=5 numbers for stock HPCC are an artifact: the INT record physically overflows at 5 hops, so the controller is reading garbage — that's a bug surface our single-field format simply doesn't have.</a:t>
+            </a:r>
+            <a:endParaRPr lang="en-US" dirty="0"/>
+          </a:p>
+        </p:txBody>
+      </p:sp>
+      <p:sp>
+        <p:nvSpPr>
+          <p:cNvPr id="4" name="Slide Number Placeholder 3"/>
+          <p:cNvSpPr>
+            <a:spLocks noGrp="1"/>
+          </p:cNvSpPr>
+          <p:nvPr>
+            <p:ph type="sldNum" sz="quarter" idx="10"/>
+          </p:nvPr>
+        </p:nvSpPr>
+        <p:spPr/>
+        <p:txBody>
+          <a:bodyPr/>
+          <a:lstStyle/>
+          <a:p>
+            <a:fld id="{F7021451-1387-4CA6-816F-3879F97B5CBC}" type="slidenum">
+              <a:rPr lang="en-US"/>
+              <a:t>19</a:t>
             </a:fld>
             <a:endParaRPr lang="en-US"/>
           </a:p>
@@ -3497,7 +3955,7 @@
                 <a:ea typeface="Calibri" pitchFamily="34" charset="-122"/>
                 <a:cs typeface="Calibri" pitchFamily="34" charset="-120"/>
               </a:rPr>
-              <a:t>THE FIX, PART 2</a:t>
+              <a:t>THE ALTERNATIVE, PART 2</a:t>
             </a:r>
             <a:endParaRPr lang="en-US" sz="1100" dirty="0"/>
           </a:p>
@@ -5033,7 +5491,7 @@
                 <a:ea typeface="Calibri" pitchFamily="34" charset="-122"/>
                 <a:cs typeface="Calibri" pitchFamily="34" charset="-120"/>
               </a:rPr>
-              <a:t>one 8-byte field replaces the per-hop record</a:t>
+              <a:t>an operating mode selected per traffic class — not a replacement</a:t>
             </a:r>
             <a:endParaRPr lang="en-US" sz="1200" dirty="0"/>
           </a:p>
@@ -6528,7 +6986,7 @@
                 <a:ea typeface="Calibri" pitchFamily="34" charset="-122"/>
                 <a:cs typeface="Calibri" pitchFamily="34" charset="-120"/>
               </a:rPr>
-              <a:t>† oracle-normalized (removes ECMP placement luck). Path-min is path-invariant — ECMP needs no design change.</a:t>
+              <a:t>† oracle-normalized (removes ECMP placement luck). Across 5 hash seeds the raw ratio is placement-dominated; HPCC-FS ≤ stock at every seed.</a:t>
             </a:r>
             <a:endParaRPr lang="en-US" sz="1050" dirty="0"/>
           </a:p>
@@ -6599,7 +7057,7 @@
                 <a:ea typeface="Calibri" pitchFamily="34" charset="-122"/>
                 <a:cs typeface="Calibri" pitchFamily="34" charset="-120"/>
               </a:rPr>
-              <a:t>IS IT A TRICK?</a:t>
+              <a:t>RESULTS</a:t>
             </a:r>
             <a:endParaRPr lang="en-US" sz="1100" dirty="0"/>
           </a:p>
@@ -6638,30 +7096,85 @@
                 <a:ea typeface="Calibri" pitchFamily="34" charset="-122"/>
                 <a:cs typeface="Calibri" pitchFamily="34" charset="-120"/>
               </a:rPr>
-              <a:t>Ablation, sensitivity, and HPCC’s home turf</a:t>
+              <a:t>The job is gated by its slowest flow: −21% JCT</a:t>
             </a:r>
             <a:endParaRPr lang="en-US" sz="2700" dirty="0"/>
           </a:p>
         </p:txBody>
       </p:sp>
-      <p:sp>
-        <p:nvSpPr>
-          <p:cNvPr id="4" name="Shape 2"/>
-          <p:cNvSpPr/>
-          <p:nvPr/>
-        </p:nvSpPr>
-        <p:spPr>
-          <a:xfrm>
-            <a:off x="548640" y="1325880"/>
-            <a:ext cx="2606040" cy="2743200"/>
+      <p:graphicFrame>
+        <p:nvGraphicFramePr>
+          <p:cNvPr id="4" name="Chart 0" descr=""/>
+          <p:cNvGraphicFramePr/>
+          <p:nvPr/>
+        </p:nvGraphicFramePr>
+        <p:xfrm>
+          <a:off x="502920" y="1325880"/>
+          <a:ext cx="5120640" cy="3017520"/>
+        </p:xfrm>
+        <a:graphic xmlns:a="http://schemas.openxmlformats.org/drawingml/2006/main">
+          <a:graphicData uri="http://schemas.openxmlformats.org/drawingml/2006/chart">
+            <c:chart xmlns:c="http://schemas.openxmlformats.org/drawingml/2006/chart" r:id="rId1"/>
+          </a:graphicData>
+        </a:graphic>
+      </p:graphicFrame>
+      <p:sp>
+        <p:nvSpPr>
+          <p:cNvPr id="5" name="Text 2"/>
+          <p:cNvSpPr/>
+          <p:nvPr/>
+        </p:nvSpPr>
+        <p:spPr>
+          <a:xfrm>
+            <a:off x="320040" y="4416552"/>
+            <a:ext cx="5486400" cy="320040"/>
+          </a:xfrm>
+          <a:prstGeom prst="rect">
+            <a:avLst/>
+          </a:prstGeom>
+          <a:noFill/>
+          <a:ln/>
+        </p:spPr>
+        <p:txBody>
+          <a:bodyPr wrap="square" rtlCol="0" anchor="ctr"/>
+          <a:lstStyle/>
+          <a:p>
+            <a:pPr algn="ctr" indent="0" marL="0">
+              <a:buNone/>
+            </a:pPr>
+            <a:r>
+              <a:rPr lang="en-US" sz="1050" i="1" dirty="0">
+                <a:solidFill>
+                  <a:srgbClr val="5B6675"/>
+                </a:solidFill>
+                <a:latin typeface="Calibri" pitchFamily="34" charset="0"/>
+                <a:ea typeface="Calibri" pitchFamily="34" charset="-122"/>
+                <a:cs typeface="Calibri" pitchFamily="34" charset="-120"/>
+              </a:rPr>
+              <a:t>16-flow ring allreduce, k=4 fat-tree — JCT = slowest flow (ms), 5 ECMP hash seeds</a:t>
+            </a:r>
+            <a:endParaRPr lang="en-US" sz="1050" dirty="0"/>
+          </a:p>
+        </p:txBody>
+      </p:sp>
+      <p:sp>
+        <p:nvSpPr>
+          <p:cNvPr id="6" name="Shape 3"/>
+          <p:cNvSpPr/>
+          <p:nvPr/>
+        </p:nvSpPr>
+        <p:spPr>
+          <a:xfrm>
+            <a:off x="5806440" y="1325880"/>
+            <a:ext cx="2880360" cy="896112"/>
           </a:xfrm>
           <a:prstGeom prst="roundRect">
             <a:avLst>
-              <a:gd name="adj" fmla="val 3158"/>
+              <a:gd name="adj" fmla="val 9184"/>
             </a:avLst>
           </a:prstGeom>
           <a:solidFill>
-            <a:srgbClr val="EEF3FB"/>
+            <a:srgbClr val="E9F0F8"/>
           </a:solidFill>
           <a:ln/>
           <a:effectLst>
@@ -6675,14 +7188,14 @@
       </p:sp>
       <p:sp>
         <p:nvSpPr>
-          <p:cNvPr id="5" name="Text 3"/>
-          <p:cNvSpPr/>
-          <p:nvPr/>
-        </p:nvSpPr>
-        <p:spPr>
-          <a:xfrm>
-            <a:off x="768096" y="1508760"/>
-            <a:ext cx="2194560" cy="2377440"/>
+          <p:cNvPr id="7" name="Text 4"/>
+          <p:cNvSpPr/>
+          <p:nvPr/>
+        </p:nvSpPr>
+        <p:spPr>
+          <a:xfrm>
+            <a:off x="5989320" y="1399032"/>
+            <a:ext cx="2560320" cy="786384"/>
           </a:xfrm>
           <a:prstGeom prst="rect">
             <a:avLst/>
@@ -6691,37 +7204,31 @@
           <a:ln/>
         </p:spPr>
         <p:txBody>
-          <a:bodyPr wrap="square" lIns="0" tIns="0" rIns="0" bIns="0" rtlCol="0" anchor="t"/>
+          <a:bodyPr wrap="square" lIns="0" tIns="0" rIns="0" bIns="0" rtlCol="0" anchor="ctr"/>
           <a:lstStyle/>
           <a:p>
             <a:pPr indent="0" marL="0">
-              <a:spcAft>
-                <a:spcPts val="600"/>
-              </a:spcAft>
-              <a:buNone/>
-            </a:pPr>
-            <a:r>
-              <a:rPr lang="en-US" sz="1350" b="1" dirty="0">
-                <a:solidFill>
-                  <a:srgbClr val="1E2761"/>
-                </a:solidFill>
-                <a:latin typeface="Calibri" pitchFamily="34" charset="0"/>
-                <a:ea typeface="Calibri" pitchFamily="34" charset="-122"/>
-                <a:cs typeface="Calibri" pitchFamily="34" charset="-120"/>
-              </a:rPr>
-              <a:t>Rate-only is necessary</a:t>
-            </a:r>
-            <a:endParaRPr lang="en-US" sz="1350" dirty="0"/>
+              <a:buNone/>
+            </a:pPr>
+            <a:r>
+              <a:rPr lang="en-US" sz="1700" b="1" dirty="0">
+                <a:solidFill>
+                  <a:srgbClr val="4F81BD"/>
+                </a:solidFill>
+                <a:latin typeface="Cambria" pitchFamily="34" charset="0"/>
+                <a:ea typeface="Cambria" pitchFamily="34" charset="-122"/>
+                <a:cs typeface="Cambria" pitchFamily="34" charset="-120"/>
+              </a:rPr>
+              <a:t>−21%</a:t>
+            </a:r>
+            <a:endParaRPr lang="en-US" sz="1700" dirty="0"/>
           </a:p>
           <a:p>
             <a:pPr indent="0" marL="0">
-              <a:spcAft>
-                <a:spcPts val="600"/>
-              </a:spcAft>
-              <a:buNone/>
-            </a:pPr>
-            <a:r>
-              <a:rPr lang="en-US" sz="1150" dirty="0">
+              <a:buNone/>
+            </a:pPr>
+            <a:r>
+              <a:rPr lang="en-US" sz="1050" dirty="0">
                 <a:solidFill>
                   <a:srgbClr val="1F2733"/>
                 </a:solidFill>
@@ -6729,47 +7236,30 @@
                 <a:ea typeface="Calibri" pitchFamily="34" charset="-122"/>
                 <a:cs typeface="Calibri" pitchFamily="34" charset="-120"/>
               </a:rPr>
-              <a:t>Re-enable the per-flow window cap → 1.5–2.5×, worse with path length.</a:t>
-            </a:r>
-            <a:endParaRPr lang="en-US" sz="1350" dirty="0"/>
-          </a:p>
-          <a:p>
-            <a:pPr indent="0" marL="0">
-              <a:buNone/>
-            </a:pPr>
-            <a:r>
-              <a:rPr lang="en-US" sz="1100" dirty="0">
-                <a:solidFill>
-                  <a:srgbClr val="5B6675"/>
-                </a:solidFill>
-                <a:latin typeface="Calibri" pitchFamily="34" charset="0"/>
-                <a:ea typeface="Calibri" pitchFamily="34" charset="-122"/>
-                <a:cs typeface="Calibri" pitchFamily="34" charset="-120"/>
-              </a:rPr>
-              <a:t>var_win sizes the window from NIC line rate, not the path — the long flow gets window-bound below fair.</a:t>
-            </a:r>
-            <a:endParaRPr lang="en-US" sz="1350" dirty="0"/>
-          </a:p>
-        </p:txBody>
-      </p:sp>
-      <p:sp>
-        <p:nvSpPr>
-          <p:cNvPr id="6" name="Shape 4"/>
-          <p:cNvSpPr/>
-          <p:nvPr/>
-        </p:nvSpPr>
-        <p:spPr>
-          <a:xfrm>
-            <a:off x="3291840" y="1325880"/>
-            <a:ext cx="2606040" cy="2743200"/>
+              <a:t>mean JCT — improves at every seed (+19.5…+22.7%)</a:t>
+            </a:r>
+            <a:endParaRPr lang="en-US" sz="1700" dirty="0"/>
+          </a:p>
+        </p:txBody>
+      </p:sp>
+      <p:sp>
+        <p:nvSpPr>
+          <p:cNvPr id="8" name="Shape 5"/>
+          <p:cNvSpPr/>
+          <p:nvPr/>
+        </p:nvSpPr>
+        <p:spPr>
+          <a:xfrm>
+            <a:off x="5806440" y="2359152"/>
+            <a:ext cx="2880360" cy="896112"/>
           </a:xfrm>
           <a:prstGeom prst="roundRect">
             <a:avLst>
-              <a:gd name="adj" fmla="val 3158"/>
+              <a:gd name="adj" fmla="val 9184"/>
             </a:avLst>
           </a:prstGeom>
           <a:solidFill>
-            <a:srgbClr val="EEF3FB"/>
+            <a:srgbClr val="E9F0F8"/>
           </a:solidFill>
           <a:ln/>
           <a:effectLst>
@@ -6783,14 +7273,14 @@
       </p:sp>
       <p:sp>
         <p:nvSpPr>
-          <p:cNvPr id="7" name="Text 5"/>
-          <p:cNvSpPr/>
-          <p:nvPr/>
-        </p:nvSpPr>
-        <p:spPr>
-          <a:xfrm>
-            <a:off x="3511296" y="1508760"/>
-            <a:ext cx="2194560" cy="2377440"/>
+          <p:cNvPr id="9" name="Text 6"/>
+          <p:cNvSpPr/>
+          <p:nvPr/>
+        </p:nvSpPr>
+        <p:spPr>
+          <a:xfrm>
+            <a:off x="5989320" y="2432304"/>
+            <a:ext cx="2560320" cy="786384"/>
           </a:xfrm>
           <a:prstGeom prst="rect">
             <a:avLst/>
@@ -6799,37 +7289,31 @@
           <a:ln/>
         </p:spPr>
         <p:txBody>
-          <a:bodyPr wrap="square" lIns="0" tIns="0" rIns="0" bIns="0" rtlCol="0" anchor="t"/>
+          <a:bodyPr wrap="square" lIns="0" tIns="0" rIns="0" bIns="0" rtlCol="0" anchor="ctr"/>
           <a:lstStyle/>
           <a:p>
             <a:pPr indent="0" marL="0">
-              <a:spcAft>
-                <a:spcPts val="600"/>
-              </a:spcAft>
-              <a:buNone/>
-            </a:pPr>
-            <a:r>
-              <a:rPr lang="en-US" sz="1350" b="1" dirty="0">
-                <a:solidFill>
-                  <a:srgbClr val="1E2761"/>
-                </a:solidFill>
-                <a:latin typeface="Calibri" pitchFamily="34" charset="0"/>
-                <a:ea typeface="Calibri" pitchFamily="34" charset="-122"/>
-                <a:cs typeface="Calibri" pitchFamily="34" charset="-120"/>
-              </a:rPr>
-              <a:t>Parameters not load-bearing</a:t>
-            </a:r>
-            <a:endParaRPr lang="en-US" sz="1350" dirty="0"/>
+              <a:buNone/>
+            </a:pPr>
+            <a:r>
+              <a:rPr lang="en-US" sz="1700" b="1" dirty="0">
+                <a:solidFill>
+                  <a:srgbClr val="4F81BD"/>
+                </a:solidFill>
+                <a:latin typeface="Cambria" pitchFamily="34" charset="0"/>
+                <a:ea typeface="Cambria" pitchFamily="34" charset="-122"/>
+                <a:cs typeface="Cambria" pitchFamily="34" charset="-120"/>
+              </a:rPr>
+              <a:t>17.9–18.0 ms</a:t>
+            </a:r>
+            <a:endParaRPr lang="en-US" sz="1700" dirty="0"/>
           </a:p>
           <a:p>
             <a:pPr indent="0" marL="0">
-              <a:spcAft>
-                <a:spcPts val="600"/>
-              </a:spcAft>
-              <a:buNone/>
-            </a:pPr>
-            <a:r>
-              <a:rPr lang="en-US" sz="1150" dirty="0">
+              <a:buNone/>
+            </a:pPr>
+            <a:r>
+              <a:rPr lang="en-US" sz="1050" dirty="0">
                 <a:solidFill>
                   <a:srgbClr val="1F2733"/>
                 </a:solidFill>
@@ -6837,47 +7321,30 @@
                 <a:ea typeface="Calibri" pitchFamily="34" charset="-122"/>
                 <a:cs typeface="Calibri" pitchFamily="34" charset="-120"/>
               </a:rPr>
-              <a:t>RCP defaults α = 0.4, β = 0.226 — untuned.</a:t>
-            </a:r>
-            <a:endParaRPr lang="en-US" sz="1350" dirty="0"/>
-          </a:p>
-          <a:p>
-            <a:pPr indent="0" marL="0">
-              <a:buNone/>
-            </a:pPr>
-            <a:r>
-              <a:rPr lang="en-US" sz="1100" dirty="0">
-                <a:solidFill>
-                  <a:srgbClr val="5B6675"/>
-                </a:solidFill>
-                <a:latin typeface="Calibri" pitchFamily="34" charset="0"/>
-                <a:ea typeface="Calibri" pitchFamily="34" charset="-122"/>
-                <a:cs typeface="Calibri" pitchFamily="34" charset="-120"/>
-              </a:rPr>
-              <a:t>Sweeping α, β, startup fraction, minRate one-at-a-time: penalty stays 1.004–1.008×, PFC = 0 throughout.</a:t>
-            </a:r>
-            <a:endParaRPr lang="en-US" sz="1350" dirty="0"/>
-          </a:p>
-        </p:txBody>
-      </p:sp>
-      <p:sp>
-        <p:nvSpPr>
-          <p:cNvPr id="8" name="Shape 6"/>
-          <p:cNvSpPr/>
-          <p:nvPr/>
-        </p:nvSpPr>
-        <p:spPr>
-          <a:xfrm>
-            <a:off x="6035040" y="1325880"/>
-            <a:ext cx="2606040" cy="2743200"/>
+              <a:t>FS JCT is placement-invariant (stock 22.3–23.3)</a:t>
+            </a:r>
+            <a:endParaRPr lang="en-US" sz="1700" dirty="0"/>
+          </a:p>
+        </p:txBody>
+      </p:sp>
+      <p:sp>
+        <p:nvSpPr>
+          <p:cNvPr id="10" name="Shape 7"/>
+          <p:cNvSpPr/>
+          <p:nvPr/>
+        </p:nvSpPr>
+        <p:spPr>
+          <a:xfrm>
+            <a:off x="5806440" y="3392424"/>
+            <a:ext cx="2880360" cy="896112"/>
           </a:xfrm>
           <a:prstGeom prst="roundRect">
             <a:avLst>
-              <a:gd name="adj" fmla="val 3158"/>
+              <a:gd name="adj" fmla="val 9184"/>
             </a:avLst>
           </a:prstGeom>
           <a:solidFill>
-            <a:srgbClr val="E9F0F8"/>
+            <a:srgbClr val="E9F4EC"/>
           </a:solidFill>
           <a:ln/>
           <a:effectLst>
@@ -6891,14 +7358,14 @@
       </p:sp>
       <p:sp>
         <p:nvSpPr>
-          <p:cNvPr id="9" name="Text 7"/>
-          <p:cNvSpPr/>
-          <p:nvPr/>
-        </p:nvSpPr>
-        <p:spPr>
-          <a:xfrm>
-            <a:off x="6254496" y="1508760"/>
-            <a:ext cx="2194560" cy="2377440"/>
+          <p:cNvPr id="11" name="Text 8"/>
+          <p:cNvSpPr/>
+          <p:nvPr/>
+        </p:nvSpPr>
+        <p:spPr>
+          <a:xfrm>
+            <a:off x="5989320" y="3465576"/>
+            <a:ext cx="2560320" cy="786384"/>
           </a:xfrm>
           <a:prstGeom prst="rect">
             <a:avLst/>
@@ -6907,37 +7374,31 @@
           <a:ln/>
         </p:spPr>
         <p:txBody>
-          <a:bodyPr wrap="square" lIns="0" tIns="0" rIns="0" bIns="0" rtlCol="0" anchor="t"/>
+          <a:bodyPr wrap="square" lIns="0" tIns="0" rIns="0" bIns="0" rtlCol="0" anchor="ctr"/>
           <a:lstStyle/>
           <a:p>
             <a:pPr indent="0" marL="0">
-              <a:spcAft>
-                <a:spcPts val="600"/>
-              </a:spcAft>
-              <a:buNone/>
-            </a:pPr>
-            <a:r>
-              <a:rPr lang="en-US" sz="1350" b="1" dirty="0">
-                <a:solidFill>
-                  <a:srgbClr val="1E2761"/>
-                </a:solidFill>
-                <a:latin typeface="Calibri" pitchFamily="34" charset="0"/>
-                <a:ea typeface="Calibri" pitchFamily="34" charset="-122"/>
-                <a:cs typeface="Calibri" pitchFamily="34" charset="-120"/>
-              </a:rPr>
-              <a:t>Home turf: not a trade-off</a:t>
-            </a:r>
-            <a:endParaRPr lang="en-US" sz="1350" dirty="0"/>
+              <a:buNone/>
+            </a:pPr>
+            <a:r>
+              <a:rPr lang="en-US" sz="1700" b="1" dirty="0">
+                <a:solidFill>
+                  <a:srgbClr val="1A7F37"/>
+                </a:solidFill>
+                <a:latin typeface="Cambria" pitchFamily="34" charset="0"/>
+                <a:ea typeface="Cambria" pitchFamily="34" charset="-122"/>
+                <a:cs typeface="Cambria" pitchFamily="34" charset="-120"/>
+              </a:rPr>
+              <a:t>~3× faster</a:t>
+            </a:r>
+            <a:endParaRPr lang="en-US" sz="1700" dirty="0"/>
           </a:p>
           <a:p>
             <a:pPr indent="0" marL="0">
-              <a:spcAft>
-                <a:spcPts val="400"/>
-              </a:spcAft>
-              <a:buNone/>
-            </a:pPr>
-            <a:r>
-              <a:rPr lang="en-US" sz="1150" dirty="0">
+              <a:buNone/>
+            </a:pPr>
+            <a:r>
+              <a:rPr lang="en-US" sz="1050" dirty="0">
                 <a:solidFill>
                   <a:srgbClr val="1F2733"/>
                 </a:solidFill>
@@ -6945,102 +7406,9 @@
                 <a:ea typeface="Calibri" pitchFamily="34" charset="-122"/>
                 <a:cs typeface="Calibri" pitchFamily="34" charset="-120"/>
               </a:rPr>
-              <a:t>Single-bottleneck incast, 8 Gbps startup:</a:t>
-            </a:r>
-            <a:endParaRPr lang="en-US" sz="1350" dirty="0"/>
-          </a:p>
-          <a:p>
-            <a:pPr indent="0" marL="0">
-              <a:buNone/>
-            </a:pPr>
-            <a:r>
-              <a:rPr lang="en-US" sz="1200" b="1" dirty="0">
-                <a:solidFill>
-                  <a:srgbClr val="4F81BD"/>
-                </a:solidFill>
-                <a:latin typeface="Calibri" pitchFamily="34" charset="0"/>
-                <a:ea typeface="Calibri" pitchFamily="34" charset="-122"/>
-                <a:cs typeface="Calibri" pitchFamily="34" charset="-120"/>
-              </a:rPr>
-              <a:t>mean FCT 242 vs 259 μs</a:t>
-            </a:r>
-            <a:endParaRPr lang="en-US" sz="1350" dirty="0"/>
-          </a:p>
-          <a:p>
-            <a:pPr indent="0" marL="0">
-              <a:spcAft>
-                <a:spcPts val="400"/>
-              </a:spcAft>
-              <a:buNone/>
-            </a:pPr>
-            <a:r>
-              <a:rPr lang="en-US" sz="1200" b="1" dirty="0">
-                <a:solidFill>
-                  <a:srgbClr val="4F81BD"/>
-                </a:solidFill>
-                <a:latin typeface="Calibri" pitchFamily="34" charset="0"/>
-                <a:ea typeface="Calibri" pitchFamily="34" charset="-122"/>
-                <a:cs typeface="Calibri" pitchFamily="34" charset="-120"/>
-              </a:rPr>
-              <a:t>peak queue 38 vs 143 KB</a:t>
-            </a:r>
-            <a:endParaRPr lang="en-US" sz="1350" dirty="0"/>
-          </a:p>
-          <a:p>
-            <a:pPr indent="0" marL="0">
-              <a:buNone/>
-            </a:pPr>
-            <a:r>
-              <a:rPr lang="en-US" sz="1100" dirty="0">
-                <a:solidFill>
-                  <a:srgbClr val="5B6675"/>
-                </a:solidFill>
-                <a:latin typeface="Calibri" pitchFamily="34" charset="0"/>
-                <a:ea typeface="Calibri" pitchFamily="34" charset="-122"/>
-                <a:cs typeface="Calibri" pitchFamily="34" charset="-120"/>
-              </a:rPr>
-              <a:t>beats HPCC’s FCT at ¼ the queue — fairness headline unchanged.</a:t>
-            </a:r>
-            <a:endParaRPr lang="en-US" sz="1350" dirty="0"/>
-          </a:p>
-        </p:txBody>
-      </p:sp>
-      <p:sp>
-        <p:nvSpPr>
-          <p:cNvPr id="10" name="Text 8"/>
-          <p:cNvSpPr/>
-          <p:nvPr/>
-        </p:nvSpPr>
-        <p:spPr>
-          <a:xfrm>
-            <a:off x="548640" y="4343400"/>
-            <a:ext cx="8092440" cy="365760"/>
-          </a:xfrm>
-          <a:prstGeom prst="rect">
-            <a:avLst/>
-          </a:prstGeom>
-          <a:noFill/>
-          <a:ln/>
-        </p:spPr>
-        <p:txBody>
-          <a:bodyPr wrap="square" rtlCol="0" anchor="ctr"/>
-          <a:lstStyle/>
-          <a:p>
-            <a:pPr algn="ctr" indent="0" marL="0">
-              <a:buNone/>
-            </a:pPr>
-            <a:r>
-              <a:rPr lang="en-US" sz="1200" i="1" dirty="0">
-                <a:solidFill>
-                  <a:srgbClr val="5B6675"/>
-                </a:solidFill>
-                <a:latin typeface="Calibri" pitchFamily="34" charset="0"/>
-                <a:ea typeface="Calibri" pitchFamily="34" charset="-122"/>
-                <a:cs typeface="Calibri" pitchFamily="34" charset="-120"/>
-              </a:rPr>
-              <a:t>Everything regenerates deterministically from the artifact — figures and tables are built from live runs.</a:t>
-            </a:r>
-            <a:endParaRPr lang="en-US" sz="1200" dirty="0"/>
+              <a:t>short background flows in this mix — max-min removes the placement lottery</a:t>
+            </a:r>
+            <a:endParaRPr lang="en-US" sz="1700" dirty="0"/>
           </a:p>
         </p:txBody>
       </p:sp>
@@ -7109,7 +7477,7 @@
                 <a:ea typeface="Calibri" pitchFamily="34" charset="-122"/>
                 <a:cs typeface="Calibri" pitchFamily="34" charset="-120"/>
               </a:rPr>
-              <a:t>POSITIONING</a:t>
+              <a:t>IS IT A TRICK?</a:t>
             </a:r>
             <a:endParaRPr lang="en-US" sz="1100" dirty="0"/>
           </a:p>
@@ -7148,7 +7516,7 @@
                 <a:ea typeface="Calibri" pitchFamily="34" charset="-122"/>
                 <a:cs typeface="Calibri" pitchFamily="34" charset="-120"/>
               </a:rPr>
-              <a:t>What this is — and what it isn’t</a:t>
+              <a:t>Ablation, sensitivity, and HPCC’s home turf</a:t>
             </a:r>
             <a:endParaRPr lang="en-US" sz="2700" dirty="0"/>
           </a:p>
@@ -7162,352 +7530,16 @@
         </p:nvSpPr>
         <p:spPr>
           <a:xfrm>
-            <a:off x="548640" y="1408176"/>
-            <a:ext cx="310896" cy="310896"/>
-          </a:xfrm>
-          <a:prstGeom prst="ellipse">
-            <a:avLst/>
-          </a:prstGeom>
-          <a:solidFill>
-            <a:srgbClr val="1E2761"/>
-          </a:solidFill>
-          <a:ln/>
-        </p:spPr>
-      </p:sp>
-      <p:sp>
-        <p:nvSpPr>
-          <p:cNvPr id="5" name="Text 3"/>
-          <p:cNvSpPr/>
-          <p:nvPr/>
-        </p:nvSpPr>
-        <p:spPr>
-          <a:xfrm>
-            <a:off x="548640" y="1394460"/>
-            <a:ext cx="310896" cy="329184"/>
-          </a:xfrm>
-          <a:prstGeom prst="rect">
-            <a:avLst/>
-          </a:prstGeom>
-          <a:noFill/>
-          <a:ln/>
-        </p:spPr>
-        <p:txBody>
-          <a:bodyPr wrap="square" lIns="0" tIns="0" rIns="0" bIns="0" rtlCol="0" anchor="ctr"/>
-          <a:lstStyle/>
-          <a:p>
-            <a:pPr algn="ctr" indent="0" marL="0">
-              <a:buNone/>
-            </a:pPr>
-            <a:r>
-              <a:rPr lang="en-US" sz="1400" b="1" dirty="0">
-                <a:solidFill>
-                  <a:srgbClr val="FFFFFF"/>
-                </a:solidFill>
-                <a:latin typeface="Calibri" pitchFamily="34" charset="0"/>
-                <a:ea typeface="Calibri" pitchFamily="34" charset="-122"/>
-                <a:cs typeface="Calibri" pitchFamily="34" charset="-120"/>
-              </a:rPr>
-              <a:t>1</a:t>
-            </a:r>
-            <a:endParaRPr lang="en-US" sz="1400" dirty="0"/>
-          </a:p>
-        </p:txBody>
-      </p:sp>
-      <p:sp>
-        <p:nvSpPr>
-          <p:cNvPr id="6" name="Text 4"/>
-          <p:cNvSpPr/>
-          <p:nvPr/>
-        </p:nvSpPr>
-        <p:spPr>
-          <a:xfrm>
-            <a:off x="1024128" y="1316736"/>
-            <a:ext cx="7589520" cy="868680"/>
-          </a:xfrm>
-          <a:prstGeom prst="rect">
-            <a:avLst/>
-          </a:prstGeom>
-          <a:noFill/>
-          <a:ln/>
-        </p:spPr>
-        <p:txBody>
-          <a:bodyPr wrap="square" lIns="0" tIns="0" rIns="0" bIns="0" rtlCol="0" anchor="ctr"/>
-          <a:lstStyle/>
-          <a:p>
-            <a:pPr indent="0" marL="0">
-              <a:buNone/>
-            </a:pPr>
-            <a:r>
-              <a:rPr lang="en-US" sz="1400" b="1" dirty="0">
-                <a:solidFill>
-                  <a:srgbClr val="1F2733"/>
-                </a:solidFill>
-                <a:latin typeface="Calibri" pitchFamily="34" charset="0"/>
-                <a:ea typeface="Calibri" pitchFamily="34" charset="-122"/>
-                <a:cs typeface="Calibri" pitchFamily="34" charset="-120"/>
-              </a:rPr>
-              <a:t>The mechanism is RCP.  </a:t>
-            </a:r>
-            <a:pPr indent="0" marL="0">
-              <a:buNone/>
-            </a:pPr>
-            <a:r>
-              <a:rPr lang="en-US" sz="1250" dirty="0">
-                <a:solidFill>
-                  <a:srgbClr val="5B6675"/>
-                </a:solidFill>
-                <a:latin typeface="Calibri" pitchFamily="34" charset="0"/>
-                <a:ea typeface="Calibri" pitchFamily="34" charset="-122"/>
-                <a:cs typeface="Calibri" pitchFamily="34" charset="-120"/>
-              </a:rPr>
-              <a:t>We claim the diagnosis and the placement, not a new control law. Placing one fair-rate signal at the switch is what closes the gap.</a:t>
-            </a:r>
-            <a:endParaRPr lang="en-US" sz="1400" dirty="0"/>
-          </a:p>
-        </p:txBody>
-      </p:sp>
-      <p:sp>
-        <p:nvSpPr>
-          <p:cNvPr id="7" name="Shape 5"/>
-          <p:cNvSpPr/>
-          <p:nvPr/>
-        </p:nvSpPr>
-        <p:spPr>
-          <a:xfrm>
-            <a:off x="548640" y="2304288"/>
-            <a:ext cx="310896" cy="310896"/>
-          </a:xfrm>
-          <a:prstGeom prst="ellipse">
-            <a:avLst/>
-          </a:prstGeom>
-          <a:solidFill>
-            <a:srgbClr val="1E2761"/>
-          </a:solidFill>
-          <a:ln/>
-        </p:spPr>
-      </p:sp>
-      <p:sp>
-        <p:nvSpPr>
-          <p:cNvPr id="8" name="Text 6"/>
-          <p:cNvSpPr/>
-          <p:nvPr/>
-        </p:nvSpPr>
-        <p:spPr>
-          <a:xfrm>
-            <a:off x="548640" y="2290572"/>
-            <a:ext cx="310896" cy="329184"/>
-          </a:xfrm>
-          <a:prstGeom prst="rect">
-            <a:avLst/>
-          </a:prstGeom>
-          <a:noFill/>
-          <a:ln/>
-        </p:spPr>
-        <p:txBody>
-          <a:bodyPr wrap="square" lIns="0" tIns="0" rIns="0" bIns="0" rtlCol="0" anchor="ctr"/>
-          <a:lstStyle/>
-          <a:p>
-            <a:pPr algn="ctr" indent="0" marL="0">
-              <a:buNone/>
-            </a:pPr>
-            <a:r>
-              <a:rPr lang="en-US" sz="1400" b="1" dirty="0">
-                <a:solidFill>
-                  <a:srgbClr val="FFFFFF"/>
-                </a:solidFill>
-                <a:latin typeface="Calibri" pitchFamily="34" charset="0"/>
-                <a:ea typeface="Calibri" pitchFamily="34" charset="-122"/>
-                <a:cs typeface="Calibri" pitchFamily="34" charset="-120"/>
-              </a:rPr>
-              <a:t>2</a:t>
-            </a:r>
-            <a:endParaRPr lang="en-US" sz="1400" dirty="0"/>
-          </a:p>
-        </p:txBody>
-      </p:sp>
-      <p:sp>
-        <p:nvSpPr>
-          <p:cNvPr id="9" name="Text 7"/>
-          <p:cNvSpPr/>
-          <p:nvPr/>
-        </p:nvSpPr>
-        <p:spPr>
-          <a:xfrm>
-            <a:off x="1024128" y="2212848"/>
-            <a:ext cx="7589520" cy="868680"/>
-          </a:xfrm>
-          <a:prstGeom prst="rect">
-            <a:avLst/>
-          </a:prstGeom>
-          <a:noFill/>
-          <a:ln/>
-        </p:spPr>
-        <p:txBody>
-          <a:bodyPr wrap="square" lIns="0" tIns="0" rIns="0" bIns="0" rtlCol="0" anchor="ctr"/>
-          <a:lstStyle/>
-          <a:p>
-            <a:pPr indent="0" marL="0">
-              <a:buNone/>
-            </a:pPr>
-            <a:r>
-              <a:rPr lang="en-US" sz="1400" b="1" dirty="0">
-                <a:solidFill>
-                  <a:srgbClr val="1F2733"/>
-                </a:solidFill>
-                <a:latin typeface="Calibri" pitchFamily="34" charset="0"/>
-                <a:ea typeface="Calibri" pitchFamily="34" charset="-122"/>
-                <a:cs typeface="Calibri" pitchFamily="34" charset="-120"/>
-              </a:rPr>
-              <a:t>Simulation-only, three topology families.  </a:t>
-            </a:r>
-            <a:pPr indent="0" marL="0">
-              <a:buNone/>
-            </a:pPr>
-            <a:r>
-              <a:rPr lang="en-US" sz="1250" dirty="0">
-                <a:solidFill>
-                  <a:srgbClr val="5B6675"/>
-                </a:solidFill>
-                <a:latin typeface="Calibri" pitchFamily="34" charset="0"/>
-                <a:ea typeface="Calibri" pitchFamily="34" charset="-122"/>
-                <a:cs typeface="Calibri" pitchFamily="34" charset="-120"/>
-              </a:rPr>
-              <a:t>No testbed; no head-to-head with Bolt / PowerTCP (would require re-implementing them). The simulator re-port reproduces the original HPCC baselines end-to-end.</a:t>
-            </a:r>
-            <a:endParaRPr lang="en-US" sz="1400" dirty="0"/>
-          </a:p>
-        </p:txBody>
-      </p:sp>
-      <p:sp>
-        <p:nvSpPr>
-          <p:cNvPr id="10" name="Shape 8"/>
-          <p:cNvSpPr/>
-          <p:nvPr/>
-        </p:nvSpPr>
-        <p:spPr>
-          <a:xfrm>
-            <a:off x="548640" y="3200400"/>
-            <a:ext cx="310896" cy="310896"/>
-          </a:xfrm>
-          <a:prstGeom prst="ellipse">
-            <a:avLst/>
-          </a:prstGeom>
-          <a:solidFill>
-            <a:srgbClr val="1E2761"/>
-          </a:solidFill>
-          <a:ln/>
-        </p:spPr>
-      </p:sp>
-      <p:sp>
-        <p:nvSpPr>
-          <p:cNvPr id="11" name="Text 9"/>
-          <p:cNvSpPr/>
-          <p:nvPr/>
-        </p:nvSpPr>
-        <p:spPr>
-          <a:xfrm>
-            <a:off x="548640" y="3186684"/>
-            <a:ext cx="310896" cy="329184"/>
-          </a:xfrm>
-          <a:prstGeom prst="rect">
-            <a:avLst/>
-          </a:prstGeom>
-          <a:noFill/>
-          <a:ln/>
-        </p:spPr>
-        <p:txBody>
-          <a:bodyPr wrap="square" lIns="0" tIns="0" rIns="0" bIns="0" rtlCol="0" anchor="ctr"/>
-          <a:lstStyle/>
-          <a:p>
-            <a:pPr algn="ctr" indent="0" marL="0">
-              <a:buNone/>
-            </a:pPr>
-            <a:r>
-              <a:rPr lang="en-US" sz="1400" b="1" dirty="0">
-                <a:solidFill>
-                  <a:srgbClr val="FFFFFF"/>
-                </a:solidFill>
-                <a:latin typeface="Calibri" pitchFamily="34" charset="0"/>
-                <a:ea typeface="Calibri" pitchFamily="34" charset="-122"/>
-                <a:cs typeface="Calibri" pitchFamily="34" charset="-120"/>
-              </a:rPr>
-              <a:t>3</a:t>
-            </a:r>
-            <a:endParaRPr lang="en-US" sz="1400" dirty="0"/>
-          </a:p>
-        </p:txBody>
-      </p:sp>
-      <p:sp>
-        <p:nvSpPr>
-          <p:cNvPr id="12" name="Text 10"/>
-          <p:cNvSpPr/>
-          <p:nvPr/>
-        </p:nvSpPr>
-        <p:spPr>
-          <a:xfrm>
-            <a:off x="1024128" y="3108960"/>
-            <a:ext cx="7589520" cy="868680"/>
-          </a:xfrm>
-          <a:prstGeom prst="rect">
-            <a:avLst/>
-          </a:prstGeom>
-          <a:noFill/>
-          <a:ln/>
-        </p:spPr>
-        <p:txBody>
-          <a:bodyPr wrap="square" lIns="0" tIns="0" rIns="0" bIns="0" rtlCol="0" anchor="ctr"/>
-          <a:lstStyle/>
-          <a:p>
-            <a:pPr indent="0" marL="0">
-              <a:buNone/>
-            </a:pPr>
-            <a:r>
-              <a:rPr lang="en-US" sz="1400" b="1" dirty="0">
-                <a:solidFill>
-                  <a:srgbClr val="1F2733"/>
-                </a:solidFill>
-                <a:latin typeface="Calibri" pitchFamily="34" charset="0"/>
-                <a:ea typeface="Calibri" pitchFamily="34" charset="-122"/>
-                <a:cs typeface="Calibri" pitchFamily="34" charset="-120"/>
-              </a:rPr>
-              <a:t>Convergence is ~4 ms, not one RTT.  </a:t>
-            </a:r>
-            <a:pPr indent="0" marL="0">
-              <a:buNone/>
-            </a:pPr>
-            <a:r>
-              <a:rPr lang="en-US" sz="1250" dirty="0">
-                <a:solidFill>
-                  <a:srgbClr val="5B6675"/>
-                </a:solidFill>
-                <a:latin typeface="Calibri" pitchFamily="34" charset="0"/>
-                <a:ea typeface="Calibri" pitchFamily="34" charset="-122"/>
-                <a:cs typeface="Calibri" pitchFamily="34" charset="-120"/>
-              </a:rPr>
-              <a:t>Fast and path-length-independent — the per-port estimate needs ~10² RTTs to settle.</a:t>
-            </a:r>
-            <a:endParaRPr lang="en-US" sz="1400" dirty="0"/>
-          </a:p>
-        </p:txBody>
-      </p:sp>
-      <p:sp>
-        <p:nvSpPr>
-          <p:cNvPr id="13" name="Shape 11"/>
-          <p:cNvSpPr/>
-          <p:nvPr/>
-        </p:nvSpPr>
-        <p:spPr>
-          <a:xfrm>
-            <a:off x="548640" y="4023360"/>
-            <a:ext cx="8092440" cy="777240"/>
+            <a:off x="548640" y="1325880"/>
+            <a:ext cx="2606040" cy="2743200"/>
           </a:xfrm>
           <a:prstGeom prst="roundRect">
             <a:avLst>
-              <a:gd name="adj" fmla="val 10588"/>
+              <a:gd name="adj" fmla="val 3158"/>
             </a:avLst>
           </a:prstGeom>
           <a:solidFill>
-            <a:srgbClr val="E9F0F8"/>
+            <a:srgbClr val="EEF3FB"/>
           </a:solidFill>
           <a:ln/>
           <a:effectLst>
@@ -7521,14 +7553,14 @@
       </p:sp>
       <p:sp>
         <p:nvSpPr>
-          <p:cNvPr id="14" name="Text 12"/>
-          <p:cNvSpPr/>
-          <p:nvPr/>
-        </p:nvSpPr>
-        <p:spPr>
-          <a:xfrm>
-            <a:off x="777240" y="4087368"/>
-            <a:ext cx="7635240" cy="658368"/>
+          <p:cNvPr id="5" name="Text 3"/>
+          <p:cNvSpPr/>
+          <p:nvPr/>
+        </p:nvSpPr>
+        <p:spPr>
+          <a:xfrm>
+            <a:off x="768096" y="1508760"/>
+            <a:ext cx="2194560" cy="2377440"/>
           </a:xfrm>
           <a:prstGeom prst="rect">
             <a:avLst/>
@@ -7537,10 +7569,13 @@
           <a:ln/>
         </p:spPr>
         <p:txBody>
-          <a:bodyPr wrap="square" lIns="0" tIns="0" rIns="0" bIns="0" rtlCol="0" anchor="ctr"/>
+          <a:bodyPr wrap="square" lIns="0" tIns="0" rIns="0" bIns="0" rtlCol="0" anchor="t"/>
           <a:lstStyle/>
           <a:p>
             <a:pPr indent="0" marL="0">
+              <a:spcAft>
+                <a:spcPts val="600"/>
+              </a:spcAft>
               <a:buNone/>
             </a:pPr>
             <a:r>
@@ -7552,27 +7587,215 @@
                 <a:ea typeface="Calibri" pitchFamily="34" charset="-122"/>
                 <a:cs typeface="Calibri" pitchFamily="34" charset="-120"/>
               </a:rPr>
-              <a:t>Future: a hybrid overlay — </a:t>
-            </a:r>
+              <a:t>Rate-only is necessary</a:t>
+            </a:r>
+            <a:endParaRPr lang="en-US" sz="1350" dirty="0"/>
+          </a:p>
+          <a:p>
             <a:pPr indent="0" marL="0">
-              <a:buNone/>
-            </a:pPr>
-            <a:r>
-              <a:rPr lang="en-US" sz="1350" dirty="0">
+              <a:spcAft>
+                <a:spcPts val="600"/>
+              </a:spcAft>
+              <a:buNone/>
+            </a:pPr>
+            <a:r>
+              <a:rPr lang="en-US" sz="1150" dirty="0">
+                <a:solidFill>
+                  <a:srgbClr val="1F2733"/>
+                </a:solidFill>
+                <a:latin typeface="Calibri" pitchFamily="34" charset="0"/>
+                <a:ea typeface="Calibri" pitchFamily="34" charset="-122"/>
+                <a:cs typeface="Calibri" pitchFamily="34" charset="-120"/>
+              </a:rPr>
+              <a:t>Re-enable the per-flow window cap → 1.5–2.5×, worse with path length.</a:t>
+            </a:r>
+            <a:endParaRPr lang="en-US" sz="1350" dirty="0"/>
+          </a:p>
+          <a:p>
+            <a:pPr indent="0" marL="0">
+              <a:buNone/>
+            </a:pPr>
+            <a:r>
+              <a:rPr lang="en-US" sz="1100" dirty="0">
+                <a:solidFill>
+                  <a:srgbClr val="5B6675"/>
+                </a:solidFill>
+                <a:latin typeface="Calibri" pitchFamily="34" charset="0"/>
+                <a:ea typeface="Calibri" pitchFamily="34" charset="-122"/>
+                <a:cs typeface="Calibri" pitchFamily="34" charset="-120"/>
+              </a:rPr>
+              <a:t>var_win sizes the window from NIC line rate, not the path — the long flow gets window-bound below fair.</a:t>
+            </a:r>
+            <a:endParaRPr lang="en-US" sz="1350" dirty="0"/>
+          </a:p>
+        </p:txBody>
+      </p:sp>
+      <p:sp>
+        <p:nvSpPr>
+          <p:cNvPr id="6" name="Shape 4"/>
+          <p:cNvSpPr/>
+          <p:nvPr/>
+        </p:nvSpPr>
+        <p:spPr>
+          <a:xfrm>
+            <a:off x="3291840" y="1325880"/>
+            <a:ext cx="2606040" cy="2743200"/>
+          </a:xfrm>
+          <a:prstGeom prst="roundRect">
+            <a:avLst>
+              <a:gd name="adj" fmla="val 3158"/>
+            </a:avLst>
+          </a:prstGeom>
+          <a:solidFill>
+            <a:srgbClr val="EEF3FB"/>
+          </a:solidFill>
+          <a:ln/>
+          <a:effectLst>
+            <a:outerShdw sx="100000" sy="100000" kx="0" ky="0" algn="bl" rotWithShape="0" blurRad="88900" dist="25400" dir="2700000">
+              <a:srgbClr val="000000">
+                <a:alpha val="14000"/>
+              </a:srgbClr>
+            </a:outerShdw>
+          </a:effectLst>
+        </p:spPr>
+      </p:sp>
+      <p:sp>
+        <p:nvSpPr>
+          <p:cNvPr id="7" name="Text 5"/>
+          <p:cNvSpPr/>
+          <p:nvPr/>
+        </p:nvSpPr>
+        <p:spPr>
+          <a:xfrm>
+            <a:off x="3511296" y="1508760"/>
+            <a:ext cx="2194560" cy="2377440"/>
+          </a:xfrm>
+          <a:prstGeom prst="rect">
+            <a:avLst/>
+          </a:prstGeom>
+          <a:noFill/>
+          <a:ln/>
+        </p:spPr>
+        <p:txBody>
+          <a:bodyPr wrap="square" lIns="0" tIns="0" rIns="0" bIns="0" rtlCol="0" anchor="t"/>
+          <a:lstStyle/>
+          <a:p>
+            <a:pPr indent="0" marL="0">
+              <a:spcAft>
+                <a:spcPts val="600"/>
+              </a:spcAft>
+              <a:buNone/>
+            </a:pPr>
+            <a:r>
+              <a:rPr lang="en-US" sz="1350" b="1" dirty="0">
                 <a:solidFill>
                   <a:srgbClr val="1E2761"/>
                 </a:solidFill>
-                <a:latin typeface="Courier New" pitchFamily="34" charset="0"/>
-                <a:ea typeface="Courier New" pitchFamily="34" charset="-122"/>
-                <a:cs typeface="Courier New" pitchFamily="34" charset="-120"/>
-              </a:rPr>
-              <a:t>rate = min(rate_HPCC, fairRate)</a:t>
-            </a:r>
+                <a:latin typeface="Calibri" pitchFamily="34" charset="0"/>
+                <a:ea typeface="Calibri" pitchFamily="34" charset="-122"/>
+                <a:cs typeface="Calibri" pitchFamily="34" charset="-120"/>
+              </a:rPr>
+              <a:t>Parameters not load-bearing</a:t>
+            </a:r>
+            <a:endParaRPr lang="en-US" sz="1350" dirty="0"/>
+          </a:p>
+          <a:p>
             <a:pPr indent="0" marL="0">
-              <a:buNone/>
-            </a:pPr>
-            <a:r>
-              <a:rPr lang="en-US" sz="1350" dirty="0">
+              <a:spcAft>
+                <a:spcPts val="600"/>
+              </a:spcAft>
+              <a:buNone/>
+            </a:pPr>
+            <a:r>
+              <a:rPr lang="en-US" sz="1150" dirty="0">
+                <a:solidFill>
+                  <a:srgbClr val="1F2733"/>
+                </a:solidFill>
+                <a:latin typeface="Calibri" pitchFamily="34" charset="0"/>
+                <a:ea typeface="Calibri" pitchFamily="34" charset="-122"/>
+                <a:cs typeface="Calibri" pitchFamily="34" charset="-120"/>
+              </a:rPr>
+              <a:t>RCP defaults α = 0.4, β = 0.226 — untuned.</a:t>
+            </a:r>
+            <a:endParaRPr lang="en-US" sz="1350" dirty="0"/>
+          </a:p>
+          <a:p>
+            <a:pPr indent="0" marL="0">
+              <a:buNone/>
+            </a:pPr>
+            <a:r>
+              <a:rPr lang="en-US" sz="1100" dirty="0">
+                <a:solidFill>
+                  <a:srgbClr val="5B6675"/>
+                </a:solidFill>
+                <a:latin typeface="Calibri" pitchFamily="34" charset="0"/>
+                <a:ea typeface="Calibri" pitchFamily="34" charset="-122"/>
+                <a:cs typeface="Calibri" pitchFamily="34" charset="-120"/>
+              </a:rPr>
+              <a:t>Sweeping α, β, startup fraction, minRate one-at-a-time: penalty stays 1.004–1.008×, PFC = 0 throughout.</a:t>
+            </a:r>
+            <a:endParaRPr lang="en-US" sz="1350" dirty="0"/>
+          </a:p>
+        </p:txBody>
+      </p:sp>
+      <p:sp>
+        <p:nvSpPr>
+          <p:cNvPr id="8" name="Shape 6"/>
+          <p:cNvSpPr/>
+          <p:nvPr/>
+        </p:nvSpPr>
+        <p:spPr>
+          <a:xfrm>
+            <a:off x="6035040" y="1325880"/>
+            <a:ext cx="2606040" cy="2743200"/>
+          </a:xfrm>
+          <a:prstGeom prst="roundRect">
+            <a:avLst>
+              <a:gd name="adj" fmla="val 3158"/>
+            </a:avLst>
+          </a:prstGeom>
+          <a:solidFill>
+            <a:srgbClr val="E9F0F8"/>
+          </a:solidFill>
+          <a:ln/>
+          <a:effectLst>
+            <a:outerShdw sx="100000" sy="100000" kx="0" ky="0" algn="bl" rotWithShape="0" blurRad="88900" dist="25400" dir="2700000">
+              <a:srgbClr val="000000">
+                <a:alpha val="14000"/>
+              </a:srgbClr>
+            </a:outerShdw>
+          </a:effectLst>
+        </p:spPr>
+      </p:sp>
+      <p:sp>
+        <p:nvSpPr>
+          <p:cNvPr id="9" name="Text 7"/>
+          <p:cNvSpPr/>
+          <p:nvPr/>
+        </p:nvSpPr>
+        <p:spPr>
+          <a:xfrm>
+            <a:off x="6254496" y="1508760"/>
+            <a:ext cx="2194560" cy="2377440"/>
+          </a:xfrm>
+          <a:prstGeom prst="rect">
+            <a:avLst/>
+          </a:prstGeom>
+          <a:noFill/>
+          <a:ln/>
+        </p:spPr>
+        <p:txBody>
+          <a:bodyPr wrap="square" lIns="0" tIns="0" rIns="0" bIns="0" rtlCol="0" anchor="t"/>
+          <a:lstStyle/>
+          <a:p>
+            <a:pPr indent="0" marL="0">
+              <a:spcAft>
+                <a:spcPts val="600"/>
+              </a:spcAft>
+              <a:buNone/>
+            </a:pPr>
+            <a:r>
+              <a:rPr lang="en-US" sz="1350" b="1" dirty="0">
                 <a:solidFill>
                   <a:srgbClr val="1E2761"/>
                 </a:solidFill>
@@ -7580,9 +7803,122 @@
                 <a:ea typeface="Calibri" pitchFamily="34" charset="-122"/>
                 <a:cs typeface="Calibri" pitchFamily="34" charset="-120"/>
               </a:rPr>
-              <a:t> — keep HPCC’s precision and the fairness; needs a path-aware window.</a:t>
+              <a:t>Home turf: not a trade-off</a:t>
             </a:r>
             <a:endParaRPr lang="en-US" sz="1350" dirty="0"/>
+          </a:p>
+          <a:p>
+            <a:pPr indent="0" marL="0">
+              <a:spcAft>
+                <a:spcPts val="400"/>
+              </a:spcAft>
+              <a:buNone/>
+            </a:pPr>
+            <a:r>
+              <a:rPr lang="en-US" sz="1150" dirty="0">
+                <a:solidFill>
+                  <a:srgbClr val="1F2733"/>
+                </a:solidFill>
+                <a:latin typeface="Calibri" pitchFamily="34" charset="0"/>
+                <a:ea typeface="Calibri" pitchFamily="34" charset="-122"/>
+                <a:cs typeface="Calibri" pitchFamily="34" charset="-120"/>
+              </a:rPr>
+              <a:t>Single-bottleneck incast, 8 Gbps startup:</a:t>
+            </a:r>
+            <a:endParaRPr lang="en-US" sz="1350" dirty="0"/>
+          </a:p>
+          <a:p>
+            <a:pPr indent="0" marL="0">
+              <a:buNone/>
+            </a:pPr>
+            <a:r>
+              <a:rPr lang="en-US" sz="1200" b="1" dirty="0">
+                <a:solidFill>
+                  <a:srgbClr val="4F81BD"/>
+                </a:solidFill>
+                <a:latin typeface="Calibri" pitchFamily="34" charset="0"/>
+                <a:ea typeface="Calibri" pitchFamily="34" charset="-122"/>
+                <a:cs typeface="Calibri" pitchFamily="34" charset="-120"/>
+              </a:rPr>
+              <a:t>mean FCT 242 vs 259 μs</a:t>
+            </a:r>
+            <a:endParaRPr lang="en-US" sz="1350" dirty="0"/>
+          </a:p>
+          <a:p>
+            <a:pPr indent="0" marL="0">
+              <a:spcAft>
+                <a:spcPts val="400"/>
+              </a:spcAft>
+              <a:buNone/>
+            </a:pPr>
+            <a:r>
+              <a:rPr lang="en-US" sz="1200" b="1" dirty="0">
+                <a:solidFill>
+                  <a:srgbClr val="4F81BD"/>
+                </a:solidFill>
+                <a:latin typeface="Calibri" pitchFamily="34" charset="0"/>
+                <a:ea typeface="Calibri" pitchFamily="34" charset="-122"/>
+                <a:cs typeface="Calibri" pitchFamily="34" charset="-120"/>
+              </a:rPr>
+              <a:t>peak queue 38 vs 143 KB</a:t>
+            </a:r>
+            <a:endParaRPr lang="en-US" sz="1350" dirty="0"/>
+          </a:p>
+          <a:p>
+            <a:pPr indent="0" marL="0">
+              <a:buNone/>
+            </a:pPr>
+            <a:r>
+              <a:rPr lang="en-US" sz="1100" dirty="0">
+                <a:solidFill>
+                  <a:srgbClr val="5B6675"/>
+                </a:solidFill>
+                <a:latin typeface="Calibri" pitchFamily="34" charset="0"/>
+                <a:ea typeface="Calibri" pitchFamily="34" charset="-122"/>
+                <a:cs typeface="Calibri" pitchFamily="34" charset="-120"/>
+              </a:rPr>
+              <a:t>beats HPCC’s FCT at ¼ the queue — fairness headline unchanged.</a:t>
+            </a:r>
+            <a:endParaRPr lang="en-US" sz="1350" dirty="0"/>
+          </a:p>
+        </p:txBody>
+      </p:sp>
+      <p:sp>
+        <p:nvSpPr>
+          <p:cNvPr id="10" name="Text 8"/>
+          <p:cNvSpPr/>
+          <p:nvPr/>
+        </p:nvSpPr>
+        <p:spPr>
+          <a:xfrm>
+            <a:off x="548640" y="4343400"/>
+            <a:ext cx="8092440" cy="365760"/>
+          </a:xfrm>
+          <a:prstGeom prst="rect">
+            <a:avLst/>
+          </a:prstGeom>
+          <a:noFill/>
+          <a:ln/>
+        </p:spPr>
+        <p:txBody>
+          <a:bodyPr wrap="square" rtlCol="0" anchor="ctr"/>
+          <a:lstStyle/>
+          <a:p>
+            <a:pPr algn="ctr" indent="0" marL="0">
+              <a:buNone/>
+            </a:pPr>
+            <a:r>
+              <a:rPr lang="en-US" sz="1200" i="1" dirty="0">
+                <a:solidFill>
+                  <a:srgbClr val="5B6675"/>
+                </a:solidFill>
+                <a:latin typeface="Calibri" pitchFamily="34" charset="0"/>
+                <a:ea typeface="Calibri" pitchFamily="34" charset="-122"/>
+                <a:cs typeface="Calibri" pitchFamily="34" charset="-120"/>
+              </a:rPr>
+              <a:t>Everything regenerates deterministically from the artifact — figures and tables are built from live runs.</a:t>
+            </a:r>
+            <a:endParaRPr lang="en-US" sz="1200" dirty="0"/>
           </a:p>
         </p:txBody>
       </p:sp>
@@ -7597,6 +7933,548 @@
 <file path=ppt/slides/slide16.xml><?xml version="1.0" encoding="utf-8"?>
 <p:sld xmlns:a="http://schemas.openxmlformats.org/drawingml/2006/main" xmlns:r="http://schemas.openxmlformats.org/officeDocument/2006/relationships" xmlns:p="http://schemas.openxmlformats.org/presentationml/2006/main">
   <p:cSld name="Slide 16">
+    <p:bg>
+      <p:bgPr>
+        <a:solidFill>
+          <a:srgbClr val="FFFFFF"/>
+        </a:solidFill>
+      </p:bgPr>
+    </p:bg>
+    <p:spTree>
+      <p:nvGrpSpPr>
+        <p:cNvPr id="1" name=""/>
+        <p:cNvGrpSpPr/>
+        <p:nvPr/>
+      </p:nvGrpSpPr>
+      <p:grpSpPr>
+        <a:xfrm>
+          <a:off x="0" y="0"/>
+          <a:ext cx="0" cy="0"/>
+          <a:chOff x="0" y="0"/>
+          <a:chExt cx="0" cy="0"/>
+        </a:xfrm>
+      </p:grpSpPr>
+      <p:sp>
+        <p:nvSpPr>
+          <p:cNvPr id="2" name="Text 0"/>
+          <p:cNvSpPr/>
+          <p:nvPr/>
+        </p:nvSpPr>
+        <p:spPr>
+          <a:xfrm>
+            <a:off x="502920" y="256032"/>
+            <a:ext cx="8138160" cy="274320"/>
+          </a:xfrm>
+          <a:prstGeom prst="rect">
+            <a:avLst/>
+          </a:prstGeom>
+          <a:noFill/>
+          <a:ln/>
+        </p:spPr>
+        <p:txBody>
+          <a:bodyPr wrap="square" lIns="0" tIns="0" rIns="0" bIns="0" rtlCol="0" anchor="ctr"/>
+          <a:lstStyle/>
+          <a:p>
+            <a:pPr indent="0" marL="0">
+              <a:buNone/>
+            </a:pPr>
+            <a:r>
+              <a:rPr lang="en-US" sz="1100" b="1" spc="300" kern="0" dirty="0">
+                <a:solidFill>
+                  <a:srgbClr val="5B6675"/>
+                </a:solidFill>
+                <a:latin typeface="Calibri" pitchFamily="34" charset="0"/>
+                <a:ea typeface="Calibri" pitchFamily="34" charset="-122"/>
+                <a:cs typeface="Calibri" pitchFamily="34" charset="-120"/>
+              </a:rPr>
+              <a:t>POSITIONING</a:t>
+            </a:r>
+            <a:endParaRPr lang="en-US" sz="1100" dirty="0"/>
+          </a:p>
+        </p:txBody>
+      </p:sp>
+      <p:sp>
+        <p:nvSpPr>
+          <p:cNvPr id="3" name="Text 1"/>
+          <p:cNvSpPr/>
+          <p:nvPr/>
+        </p:nvSpPr>
+        <p:spPr>
+          <a:xfrm>
+            <a:off x="502920" y="502920"/>
+            <a:ext cx="8138160" cy="566928"/>
+          </a:xfrm>
+          <a:prstGeom prst="rect">
+            <a:avLst/>
+          </a:prstGeom>
+          <a:noFill/>
+          <a:ln/>
+        </p:spPr>
+        <p:txBody>
+          <a:bodyPr wrap="square" lIns="0" tIns="0" rIns="0" bIns="0" rtlCol="0" anchor="ctr"/>
+          <a:lstStyle/>
+          <a:p>
+            <a:pPr indent="0" marL="0">
+              <a:buNone/>
+            </a:pPr>
+            <a:r>
+              <a:rPr lang="en-US" sz="2700" b="1" dirty="0">
+                <a:solidFill>
+                  <a:srgbClr val="1E2761"/>
+                </a:solidFill>
+                <a:latin typeface="Calibri" pitchFamily="34" charset="0"/>
+                <a:ea typeface="Calibri" pitchFamily="34" charset="-122"/>
+                <a:cs typeface="Calibri" pitchFamily="34" charset="-120"/>
+              </a:rPr>
+              <a:t>What this is — and what it isn’t</a:t>
+            </a:r>
+            <a:endParaRPr lang="en-US" sz="2700" dirty="0"/>
+          </a:p>
+        </p:txBody>
+      </p:sp>
+      <p:sp>
+        <p:nvSpPr>
+          <p:cNvPr id="4" name="Shape 2"/>
+          <p:cNvSpPr/>
+          <p:nvPr/>
+        </p:nvSpPr>
+        <p:spPr>
+          <a:xfrm>
+            <a:off x="548640" y="1408176"/>
+            <a:ext cx="310896" cy="310896"/>
+          </a:xfrm>
+          <a:prstGeom prst="ellipse">
+            <a:avLst/>
+          </a:prstGeom>
+          <a:solidFill>
+            <a:srgbClr val="1E2761"/>
+          </a:solidFill>
+          <a:ln/>
+        </p:spPr>
+      </p:sp>
+      <p:sp>
+        <p:nvSpPr>
+          <p:cNvPr id="5" name="Text 3"/>
+          <p:cNvSpPr/>
+          <p:nvPr/>
+        </p:nvSpPr>
+        <p:spPr>
+          <a:xfrm>
+            <a:off x="548640" y="1394460"/>
+            <a:ext cx="310896" cy="329184"/>
+          </a:xfrm>
+          <a:prstGeom prst="rect">
+            <a:avLst/>
+          </a:prstGeom>
+          <a:noFill/>
+          <a:ln/>
+        </p:spPr>
+        <p:txBody>
+          <a:bodyPr wrap="square" lIns="0" tIns="0" rIns="0" bIns="0" rtlCol="0" anchor="ctr"/>
+          <a:lstStyle/>
+          <a:p>
+            <a:pPr algn="ctr" indent="0" marL="0">
+              <a:buNone/>
+            </a:pPr>
+            <a:r>
+              <a:rPr lang="en-US" sz="1400" b="1" dirty="0">
+                <a:solidFill>
+                  <a:srgbClr val="FFFFFF"/>
+                </a:solidFill>
+                <a:latin typeface="Calibri" pitchFamily="34" charset="0"/>
+                <a:ea typeface="Calibri" pitchFamily="34" charset="-122"/>
+                <a:cs typeface="Calibri" pitchFamily="34" charset="-120"/>
+              </a:rPr>
+              <a:t>1</a:t>
+            </a:r>
+            <a:endParaRPr lang="en-US" sz="1400" dirty="0"/>
+          </a:p>
+        </p:txBody>
+      </p:sp>
+      <p:sp>
+        <p:nvSpPr>
+          <p:cNvPr id="6" name="Text 4"/>
+          <p:cNvSpPr/>
+          <p:nvPr/>
+        </p:nvSpPr>
+        <p:spPr>
+          <a:xfrm>
+            <a:off x="1024128" y="1316736"/>
+            <a:ext cx="7589520" cy="868680"/>
+          </a:xfrm>
+          <a:prstGeom prst="rect">
+            <a:avLst/>
+          </a:prstGeom>
+          <a:noFill/>
+          <a:ln/>
+        </p:spPr>
+        <p:txBody>
+          <a:bodyPr wrap="square" lIns="0" tIns="0" rIns="0" bIns="0" rtlCol="0" anchor="ctr"/>
+          <a:lstStyle/>
+          <a:p>
+            <a:pPr indent="0" marL="0">
+              <a:buNone/>
+            </a:pPr>
+            <a:r>
+              <a:rPr lang="en-US" sz="1400" b="1" dirty="0">
+                <a:solidFill>
+                  <a:srgbClr val="1F2733"/>
+                </a:solidFill>
+                <a:latin typeface="Calibri" pitchFamily="34" charset="0"/>
+                <a:ea typeface="Calibri" pitchFamily="34" charset="-122"/>
+                <a:cs typeface="Calibri" pitchFamily="34" charset="-120"/>
+              </a:rPr>
+              <a:t>The mechanism is RCP; HPCC-FS is a mode, not a repair.  </a:t>
+            </a:r>
+            <a:pPr indent="0" marL="0">
+              <a:buNone/>
+            </a:pPr>
+            <a:r>
+              <a:rPr lang="en-US" sz="1250" dirty="0">
+                <a:solidFill>
+                  <a:srgbClr val="5B6675"/>
+                </a:solidFill>
+                <a:latin typeface="Calibri" pitchFamily="34" charset="0"/>
+                <a:ea typeface="Calibri" pitchFamily="34" charset="-122"/>
+                <a:cs typeface="Calibri" pitchFamily="34" charset="-120"/>
+              </a:rPr>
+              <a:t>We claim the diagnosis and the placement. HPCC-FS coexists with stock HPCC per traffic class; mixed classes sharing links are future work.</a:t>
+            </a:r>
+            <a:endParaRPr lang="en-US" sz="1400" dirty="0"/>
+          </a:p>
+        </p:txBody>
+      </p:sp>
+      <p:sp>
+        <p:nvSpPr>
+          <p:cNvPr id="7" name="Shape 5"/>
+          <p:cNvSpPr/>
+          <p:nvPr/>
+        </p:nvSpPr>
+        <p:spPr>
+          <a:xfrm>
+            <a:off x="548640" y="2304288"/>
+            <a:ext cx="310896" cy="310896"/>
+          </a:xfrm>
+          <a:prstGeom prst="ellipse">
+            <a:avLst/>
+          </a:prstGeom>
+          <a:solidFill>
+            <a:srgbClr val="1E2761"/>
+          </a:solidFill>
+          <a:ln/>
+        </p:spPr>
+      </p:sp>
+      <p:sp>
+        <p:nvSpPr>
+          <p:cNvPr id="8" name="Text 6"/>
+          <p:cNvSpPr/>
+          <p:nvPr/>
+        </p:nvSpPr>
+        <p:spPr>
+          <a:xfrm>
+            <a:off x="548640" y="2290572"/>
+            <a:ext cx="310896" cy="329184"/>
+          </a:xfrm>
+          <a:prstGeom prst="rect">
+            <a:avLst/>
+          </a:prstGeom>
+          <a:noFill/>
+          <a:ln/>
+        </p:spPr>
+        <p:txBody>
+          <a:bodyPr wrap="square" lIns="0" tIns="0" rIns="0" bIns="0" rtlCol="0" anchor="ctr"/>
+          <a:lstStyle/>
+          <a:p>
+            <a:pPr algn="ctr" indent="0" marL="0">
+              <a:buNone/>
+            </a:pPr>
+            <a:r>
+              <a:rPr lang="en-US" sz="1400" b="1" dirty="0">
+                <a:solidFill>
+                  <a:srgbClr val="FFFFFF"/>
+                </a:solidFill>
+                <a:latin typeface="Calibri" pitchFamily="34" charset="0"/>
+                <a:ea typeface="Calibri" pitchFamily="34" charset="-122"/>
+                <a:cs typeface="Calibri" pitchFamily="34" charset="-120"/>
+              </a:rPr>
+              <a:t>2</a:t>
+            </a:r>
+            <a:endParaRPr lang="en-US" sz="1400" dirty="0"/>
+          </a:p>
+        </p:txBody>
+      </p:sp>
+      <p:sp>
+        <p:nvSpPr>
+          <p:cNvPr id="9" name="Text 7"/>
+          <p:cNvSpPr/>
+          <p:nvPr/>
+        </p:nvSpPr>
+        <p:spPr>
+          <a:xfrm>
+            <a:off x="1024128" y="2212848"/>
+            <a:ext cx="7589520" cy="868680"/>
+          </a:xfrm>
+          <a:prstGeom prst="rect">
+            <a:avLst/>
+          </a:prstGeom>
+          <a:noFill/>
+          <a:ln/>
+        </p:spPr>
+        <p:txBody>
+          <a:bodyPr wrap="square" lIns="0" tIns="0" rIns="0" bIns="0" rtlCol="0" anchor="ctr"/>
+          <a:lstStyle/>
+          <a:p>
+            <a:pPr indent="0" marL="0">
+              <a:buNone/>
+            </a:pPr>
+            <a:r>
+              <a:rPr lang="en-US" sz="1400" b="1" dirty="0">
+                <a:solidFill>
+                  <a:srgbClr val="1F2733"/>
+                </a:solidFill>
+                <a:latin typeface="Calibri" pitchFamily="34" charset="0"/>
+                <a:ea typeface="Calibri" pitchFamily="34" charset="-122"/>
+                <a:cs typeface="Calibri" pitchFamily="34" charset="-120"/>
+              </a:rPr>
+              <a:t>Simulation-only, three topology families.  </a:t>
+            </a:r>
+            <a:pPr indent="0" marL="0">
+              <a:buNone/>
+            </a:pPr>
+            <a:r>
+              <a:rPr lang="en-US" sz="1250" dirty="0">
+                <a:solidFill>
+                  <a:srgbClr val="5B6675"/>
+                </a:solidFill>
+                <a:latin typeface="Calibri" pitchFamily="34" charset="0"/>
+                <a:ea typeface="Calibri" pitchFamily="34" charset="-122"/>
+                <a:cs typeface="Calibri" pitchFamily="34" charset="-120"/>
+              </a:rPr>
+              <a:t>No testbed; no head-to-head with Bolt / PowerTCP (would require re-implementing them). The simulator re-port reproduces the original HPCC baselines end-to-end.</a:t>
+            </a:r>
+            <a:endParaRPr lang="en-US" sz="1400" dirty="0"/>
+          </a:p>
+        </p:txBody>
+      </p:sp>
+      <p:sp>
+        <p:nvSpPr>
+          <p:cNvPr id="10" name="Shape 8"/>
+          <p:cNvSpPr/>
+          <p:nvPr/>
+        </p:nvSpPr>
+        <p:spPr>
+          <a:xfrm>
+            <a:off x="548640" y="3200400"/>
+            <a:ext cx="310896" cy="310896"/>
+          </a:xfrm>
+          <a:prstGeom prst="ellipse">
+            <a:avLst/>
+          </a:prstGeom>
+          <a:solidFill>
+            <a:srgbClr val="1E2761"/>
+          </a:solidFill>
+          <a:ln/>
+        </p:spPr>
+      </p:sp>
+      <p:sp>
+        <p:nvSpPr>
+          <p:cNvPr id="11" name="Text 9"/>
+          <p:cNvSpPr/>
+          <p:nvPr/>
+        </p:nvSpPr>
+        <p:spPr>
+          <a:xfrm>
+            <a:off x="548640" y="3186684"/>
+            <a:ext cx="310896" cy="329184"/>
+          </a:xfrm>
+          <a:prstGeom prst="rect">
+            <a:avLst/>
+          </a:prstGeom>
+          <a:noFill/>
+          <a:ln/>
+        </p:spPr>
+        <p:txBody>
+          <a:bodyPr wrap="square" lIns="0" tIns="0" rIns="0" bIns="0" rtlCol="0" anchor="ctr"/>
+          <a:lstStyle/>
+          <a:p>
+            <a:pPr algn="ctr" indent="0" marL="0">
+              <a:buNone/>
+            </a:pPr>
+            <a:r>
+              <a:rPr lang="en-US" sz="1400" b="1" dirty="0">
+                <a:solidFill>
+                  <a:srgbClr val="FFFFFF"/>
+                </a:solidFill>
+                <a:latin typeface="Calibri" pitchFamily="34" charset="0"/>
+                <a:ea typeface="Calibri" pitchFamily="34" charset="-122"/>
+                <a:cs typeface="Calibri" pitchFamily="34" charset="-120"/>
+              </a:rPr>
+              <a:t>3</a:t>
+            </a:r>
+            <a:endParaRPr lang="en-US" sz="1400" dirty="0"/>
+          </a:p>
+        </p:txBody>
+      </p:sp>
+      <p:sp>
+        <p:nvSpPr>
+          <p:cNvPr id="12" name="Text 10"/>
+          <p:cNvSpPr/>
+          <p:nvPr/>
+        </p:nvSpPr>
+        <p:spPr>
+          <a:xfrm>
+            <a:off x="1024128" y="3108960"/>
+            <a:ext cx="7589520" cy="868680"/>
+          </a:xfrm>
+          <a:prstGeom prst="rect">
+            <a:avLst/>
+          </a:prstGeom>
+          <a:noFill/>
+          <a:ln/>
+        </p:spPr>
+        <p:txBody>
+          <a:bodyPr wrap="square" lIns="0" tIns="0" rIns="0" bIns="0" rtlCol="0" anchor="ctr"/>
+          <a:lstStyle/>
+          <a:p>
+            <a:pPr indent="0" marL="0">
+              <a:buNone/>
+            </a:pPr>
+            <a:r>
+              <a:rPr lang="en-US" sz="1400" b="1" dirty="0">
+                <a:solidFill>
+                  <a:srgbClr val="1F2733"/>
+                </a:solidFill>
+                <a:latin typeface="Calibri" pitchFamily="34" charset="0"/>
+                <a:ea typeface="Calibri" pitchFamily="34" charset="-122"/>
+                <a:cs typeface="Calibri" pitchFamily="34" charset="-120"/>
+              </a:rPr>
+              <a:t>Convergence is ~4 ms, not one RTT.  </a:t>
+            </a:r>
+            <a:pPr indent="0" marL="0">
+              <a:buNone/>
+            </a:pPr>
+            <a:r>
+              <a:rPr lang="en-US" sz="1250" dirty="0">
+                <a:solidFill>
+                  <a:srgbClr val="5B6675"/>
+                </a:solidFill>
+                <a:latin typeface="Calibri" pitchFamily="34" charset="0"/>
+                <a:ea typeface="Calibri" pitchFamily="34" charset="-122"/>
+                <a:cs typeface="Calibri" pitchFamily="34" charset="-120"/>
+              </a:rPr>
+              <a:t>Fast and path-length-independent — the per-port estimate needs ~10² RTTs to settle.</a:t>
+            </a:r>
+            <a:endParaRPr lang="en-US" sz="1400" dirty="0"/>
+          </a:p>
+        </p:txBody>
+      </p:sp>
+      <p:sp>
+        <p:nvSpPr>
+          <p:cNvPr id="13" name="Shape 11"/>
+          <p:cNvSpPr/>
+          <p:nvPr/>
+        </p:nvSpPr>
+        <p:spPr>
+          <a:xfrm>
+            <a:off x="548640" y="4023360"/>
+            <a:ext cx="8092440" cy="777240"/>
+          </a:xfrm>
+          <a:prstGeom prst="roundRect">
+            <a:avLst>
+              <a:gd name="adj" fmla="val 10588"/>
+            </a:avLst>
+          </a:prstGeom>
+          <a:solidFill>
+            <a:srgbClr val="E9F0F8"/>
+          </a:solidFill>
+          <a:ln/>
+          <a:effectLst>
+            <a:outerShdw sx="100000" sy="100000" kx="0" ky="0" algn="bl" rotWithShape="0" blurRad="88900" dist="25400" dir="2700000">
+              <a:srgbClr val="000000">
+                <a:alpha val="14000"/>
+              </a:srgbClr>
+            </a:outerShdw>
+          </a:effectLst>
+        </p:spPr>
+      </p:sp>
+      <p:sp>
+        <p:nvSpPr>
+          <p:cNvPr id="14" name="Text 12"/>
+          <p:cNvSpPr/>
+          <p:nvPr/>
+        </p:nvSpPr>
+        <p:spPr>
+          <a:xfrm>
+            <a:off x="777240" y="4087368"/>
+            <a:ext cx="7635240" cy="658368"/>
+          </a:xfrm>
+          <a:prstGeom prst="rect">
+            <a:avLst/>
+          </a:prstGeom>
+          <a:noFill/>
+          <a:ln/>
+        </p:spPr>
+        <p:txBody>
+          <a:bodyPr wrap="square" lIns="0" tIns="0" rIns="0" bIns="0" rtlCol="0" anchor="ctr"/>
+          <a:lstStyle/>
+          <a:p>
+            <a:pPr indent="0" marL="0">
+              <a:buNone/>
+            </a:pPr>
+            <a:r>
+              <a:rPr lang="en-US" sz="1350" b="1" dirty="0">
+                <a:solidFill>
+                  <a:srgbClr val="1E2761"/>
+                </a:solidFill>
+                <a:latin typeface="Calibri" pitchFamily="34" charset="0"/>
+                <a:ea typeface="Calibri" pitchFamily="34" charset="-122"/>
+                <a:cs typeface="Calibri" pitchFamily="34" charset="-120"/>
+              </a:rPr>
+              <a:t>Future: a hybrid overlay — </a:t>
+            </a:r>
+            <a:pPr indent="0" marL="0">
+              <a:buNone/>
+            </a:pPr>
+            <a:r>
+              <a:rPr lang="en-US" sz="1350" dirty="0">
+                <a:solidFill>
+                  <a:srgbClr val="1E2761"/>
+                </a:solidFill>
+                <a:latin typeface="Courier New" pitchFamily="34" charset="0"/>
+                <a:ea typeface="Courier New" pitchFamily="34" charset="-122"/>
+                <a:cs typeface="Courier New" pitchFamily="34" charset="-120"/>
+              </a:rPr>
+              <a:t>rate = min(rate_HPCC, fairRate)</a:t>
+            </a:r>
+            <a:pPr indent="0" marL="0">
+              <a:buNone/>
+            </a:pPr>
+            <a:r>
+              <a:rPr lang="en-US" sz="1350" dirty="0">
+                <a:solidFill>
+                  <a:srgbClr val="1E2761"/>
+                </a:solidFill>
+                <a:latin typeface="Calibri" pitchFamily="34" charset="0"/>
+                <a:ea typeface="Calibri" pitchFamily="34" charset="-122"/>
+                <a:cs typeface="Calibri" pitchFamily="34" charset="-120"/>
+              </a:rPr>
+              <a:t> — keep HPCC’s precision and the fairness; needs a path-aware window.</a:t>
+            </a:r>
+            <a:endParaRPr lang="en-US" sz="1350" dirty="0"/>
+          </a:p>
+        </p:txBody>
+      </p:sp>
+    </p:spTree>
+  </p:cSld>
+  <p:clrMapOvr>
+    <a:masterClrMapping/>
+  </p:clrMapOvr>
+</p:sld>
+</file>
+
+<file path=ppt/slides/slide17.xml><?xml version="1.0" encoding="utf-8"?>
+<p:sld xmlns:a="http://schemas.openxmlformats.org/drawingml/2006/main" xmlns:r="http://schemas.openxmlformats.org/officeDocument/2006/relationships" xmlns:p="http://schemas.openxmlformats.org/presentationml/2006/main">
+  <p:cSld name="Slide 17">
     <p:bg>
       <p:bgPr>
         <a:solidFill>
@@ -7690,7 +8568,7 @@
                 <a:ea typeface="Calibri" pitchFamily="34" charset="-122"/>
                 <a:cs typeface="Calibri" pitchFamily="34" charset="-120"/>
               </a:rPr>
-              <a:t>One field, one scalar — fairness restored</a:t>
+              <a:t>One field, one scalar — a coexisting fairness mode</a:t>
             </a:r>
             <a:endParaRPr lang="en-US" sz="2700" dirty="0"/>
           </a:p>
@@ -7990,7 +8868,7 @@
                 <a:ea typeface="Calibri" pitchFamily="34" charset="-122"/>
                 <a:cs typeface="Calibri" pitchFamily="34" charset="-120"/>
               </a:rPr>
-              <a:t>One RCP fair-rate field, one scalar per port → 1.005×, zero PFC, robust, stock path untouched.</a:t>
+              <a:t>A per-class mode alongside HPCC: 1.005×, zero PFC, −21% coflow JCT, stock path untouched.</a:t>
             </a:r>
             <a:endParaRPr lang="en-US" sz="1300" dirty="0"/>
           </a:p>
@@ -8096,9 +8974,9 @@
 </p:sld>
 </file>
 
-<file path=ppt/slides/slide17.xml><?xml version="1.0" encoding="utf-8"?>
+<file path=ppt/slides/slide18.xml><?xml version="1.0" encoding="utf-8"?>
 <p:sld xmlns:a="http://schemas.openxmlformats.org/drawingml/2006/main" xmlns:r="http://schemas.openxmlformats.org/officeDocument/2006/relationships" xmlns:p="http://schemas.openxmlformats.org/presentationml/2006/main">
-  <p:cSld name="Slide 17">
+  <p:cSld name="Slide 18">
     <p:bg>
       <p:bgPr>
         <a:solidFill>
@@ -8200,7 +9078,7 @@
       </p:sp>
       <p:graphicFrame>
         <p:nvGraphicFramePr>
-          <p:cNvPr id="18" name="Table 0"/>
+          <p:cNvPr id="19" name="Table 0"/>
           <p:cNvGraphicFramePr>
             <a:graphicFrameLocks noGrp="1"/>
           </p:cNvGraphicFramePr>
@@ -9939,9 +10817,9 @@
 </p:sld>
 </file>
 
-<file path=ppt/slides/slide18.xml><?xml version="1.0" encoding="utf-8"?>
+<file path=ppt/slides/slide19.xml><?xml version="1.0" encoding="utf-8"?>
 <p:sld xmlns:a="http://schemas.openxmlformats.org/drawingml/2006/main" xmlns:r="http://schemas.openxmlformats.org/officeDocument/2006/relationships" xmlns:p="http://schemas.openxmlformats.org/presentationml/2006/main">
-  <p:cSld name="Slide 18">
+  <p:cSld name="Slide 19">
     <p:bg>
       <p:bgPr>
         <a:solidFill>
@@ -14683,7 +15561,7 @@
                 <a:ea typeface="Calibri" pitchFamily="34" charset="-122"/>
                 <a:cs typeface="Calibri" pitchFamily="34" charset="-120"/>
               </a:rPr>
-              <a:t>THE FIX, PART 1</a:t>
+              <a:t>THE ALTERNATIVE, PART 1</a:t>
             </a:r>
             <a:endParaRPr lang="en-US" sz="1100" dirty="0"/>
           </a:p>

</xml_diff>

<commit_message>
sync: mixed-mode coexistence, defensive-review corrections, updated slides
- cc_mode 12 / IntHeader::FSMIX per-class dispatch + run_mixed_mode.py
- paper.tex/pdf, paper-ipccc.tex/pdf: coexistence negative result, N=1
  single-bottleneck control, corrected queue peak (46 KB), convergence
  (sub-ms), ECMP seed claim, WebSearch metric disclosure, RCP-identity
  withdrawn, Bolt repositioned
- talk deck + PDF: matching corrections
- docs/paper.pdf, docs/slides.pdf refreshed
</commit_message>
<xml_diff>
--- a/examples/hpcc/hpcc-fs/talk/ipccc2026-talk.pptx
+++ b/examples/hpcc/hpcc-fs/talk/ipccc2026-talk.pptx
@@ -2017,7 +2017,7 @@
           <a:p>
             <a:r>
               <a:rPr lang="en-US" dirty="0"/>
-              <a:t>Three defensibility checks. One: disabling the window is necessary, not a convenience — put it back and the penalty returns, growing with path length, because HPCC's window is sized for the NIC, not the path. Two: we did not tune RCP — the textbook defaults, and one-at-a-time sweeps barely move the result. Three: the cost question — on HPCC's home turf, a single-bottleneck incast, a moderate startup rate makes HPCC-FS match or beat HPCC's FCT while holding a quarter of the queue. On what we measured, the fairness fix is not a trade-off.</a:t>
+              <a:t>Three defensibility checks. One: disabling the window is necessary, not a convenience — put it back and the penalty returns, growing with path length, because HPCC's window is sized for the NIC, not the path. Two: we did not tune RCP — the textbook defaults, and one-at-a-time sweeps barely move the result. Three: the cost question — on HPCC's home turf, a single-bottleneck incast, a moderate startup rate makes HPCC-FS match or beat HPCC's FCT while holding a quarter of the queue. On what we measured, the fairness mode is not a trade-off.</a:t>
             </a:r>
             <a:endParaRPr lang="en-US" dirty="0"/>
           </a:p>
@@ -2193,7 +2193,7 @@
           <a:p>
             <a:r>
               <a:rPr lang="en-US" dirty="0"/>
-              <a:t>To close: a real, robust fairness failure in the state of the art; evidence that the endpoint can't fix it because the endpoint can't see the flow count; and a deliberately minimal switch fix — one field, one scalar — that lands within half a percent of the max-min oracle with zero PFC, leaving stock HPCC byte-for-byte intact. Everything is in the artifact, including a full reproduction of the original HPCC baselines. Happy to take questions.</a:t>
+              <a:t>To close: a real, robust fairness failure in the state of the art; evidence that the endpoint can't fix it because the endpoint can't see the flow count; and a deliberately minimal switch mode — one field, one scalar — that lands within about one percent of the max-min oracle with zero PFC, leaving stock HPCC byte-for-byte intact. One caveat we measured and report: on an unreserved shared queue the two modes do not each get a fair share, so HPCC-FS needs a reserved bandwidth share. Everything is in the artifact, including a full reproduction of the original HPCC baselines. Happy to take questions.</a:t>
             </a:r>
             <a:endParaRPr lang="en-US" dirty="0"/>
           </a:p>
@@ -6986,7 +6986,7 @@
                 <a:ea typeface="Calibri" pitchFamily="34" charset="-122"/>
                 <a:cs typeface="Calibri" pitchFamily="34" charset="-120"/>
               </a:rPr>
-              <a:t>† oracle-normalized (removes ECMP placement luck). Across 5 hash seeds the raw ratio is placement-dominated; HPCC-FS ≤ stock at every seed.</a:t>
+              <a:t>† oracle-normalized (removes ECMP placement luck). Across 5 hash seeds the raw ratio is placement-dominated; HPCC-FS ≤ stock at 4 of 5 seeds (the 5th is uncontended).</a:t>
             </a:r>
             <a:endParaRPr lang="en-US" sz="1050" dirty="0"/>
           </a:p>
@@ -8348,7 +8348,7 @@
                 <a:ea typeface="Calibri" pitchFamily="34" charset="-122"/>
                 <a:cs typeface="Calibri" pitchFamily="34" charset="-120"/>
               </a:rPr>
-              <a:t>Convergence is ~4 ms, not one RTT.  </a:t>
+              <a:t>Convergence is sub-ms, not one RTT.  </a:t>
             </a:r>
             <a:pPr indent="0" marL="0">
               <a:buNone/>
@@ -8362,7 +8362,7 @@
                 <a:ea typeface="Calibri" pitchFamily="34" charset="-122"/>
                 <a:cs typeface="Calibri" pitchFamily="34" charset="-120"/>
               </a:rPr>
-              <a:t>Fast and path-length-independent — the per-port estimate needs ~10² RTTs to settle.</a:t>
+              <a:t>Within 5% of fair share in ~0.6 ms (~30 RTTs); path-length-independent.</a:t>
             </a:r>
             <a:endParaRPr lang="en-US" sz="1400" dirty="0"/>
           </a:p>
@@ -15168,7 +15168,7 @@
                 <a:ea typeface="Calibri" pitchFamily="34" charset="-122"/>
                 <a:cs typeface="Calibri" pitchFamily="34" charset="-120"/>
               </a:rPr>
-              <a:t>Two structural reasons sender-only cannot work</a:t>
+              <a:t>Two structural reasons every sender-only fix stalls</a:t>
             </a:r>
             <a:endParaRPr lang="en-US" sz="2700" dirty="0"/>
           </a:p>

</xml_diff>

<commit_message>
RDMA-RCP: empirical-study restructure, new experiments, docs
- Paper (both versions, 10pp): retitled 'Multi-Bottleneck Fairness on RDMA
  Fabrics: An Empirical Study'; HPCC-FS renamed RDMA-RCP (implementation
  name unchanged, cc_mode 11)
- New experiments + engine knobs (all additive, defaults preserve stock):
  run_cc_baselines.py (DCQCN/TIMELY/DCTCP endemic table),
  run_vrcp.py (mb_mode 6 sender-side RCP mirror -- consistency result),
  fs_rcp_window (canonical cwnd=R*RTT endpoint),
  dwrr_weights (weighted-DRR egress; reservation alone insufficient)
- README + project page rewritten around the three findings and the
  sliced-telemetry coexistence boundary
- Talk deck source + pptx updated (PDF pending re-export)
</commit_message>
<xml_diff>
--- a/examples/hpcc/hpcc-fs/talk/ipccc2026-talk.pptx
+++ b/examples/hpcc/hpcc-fs/talk/ipccc2026-talk.pptx
@@ -841,7 +841,7 @@
               <c:strCache>
                 <c:ptCount val="1"/>
                 <c:pt idx="0">
-                  <c:v>HPCC-FS</c:v>
+                  <c:v>RDMA-RCP</c:v>
                 </c:pt>
               </c:strCache>
             </c:strRef>
@@ -1753,7 +1753,7 @@
           <a:p>
             <a:r>
               <a:rPr lang="en-US" dirty="0"/>
-              <a:t>The headline. Blue bars: HPCC-FS sits at 1.003 to 1.007 across the entire sweep — including N of 5 and 6 where stock HPCC's wire format breaks, because one field doesn't grow with path length. Zero PFC everywhere. And an important control: HPCC-PINT, which also carries a single compressed field but still carries *load*, stays at 1.8x — so it's not about telemetry size, it's about carrying a fair share instead of a load sample.</a:t>
+              <a:t>The headline — and it is not just HPCC: on the same benchmark DCQCN runs 1.7 to 2.3, TIMELY 1.8 to 2.0, DCTCP 1.6 to 1.8, all growing with N. Multi-bottleneck unfairness is endemic to deployable RDMA CC. Blue bars: RDMA-RCP sits at 1.003 to 1.007 across the entire sweep — including N of 5 and 6 where stock HPCC's wire format breaks, because one field doesn't grow with path length. Zero PFC everywhere. And an important control: HPCC-PINT, which also carries a single compressed field but still carries *load*, stays at 1.8x — so it's not about telemetry size, it's about carrying a fair share instead of a load sample.</a:t>
             </a:r>
             <a:endParaRPr lang="en-US" dirty="0"/>
           </a:p>
@@ -1841,7 +1841,7 @@
           <a:p>
             <a:r>
               <a:rPr lang="en-US" dirty="0"/>
-              <a:t>Robustness and generalization. Left: six perturbations — asymmetric sizes, staggered starts, including the 3.5x small-flow worst case — HPCC-FS stays within about one percent of the oracle. Right: a 3-tier tree and a k=4 ECMP fat-tree, where the oracle-normalized penalty lands at 1.001; the path-min aggregation is inherently path-invariant, so ECMP needed no design work. Zero PFC across all of it.</a:t>
+              <a:t>Robustness and generalization. Left: six perturbations — asymmetric sizes, staggered starts, including the 3.5x small-flow worst case — RDMA-RCP stays within about one percent of the oracle. Right: a 3-tier tree and a k=4 ECMP fat-tree, where the oracle-normalized penalty lands at 1.001; the path-min aggregation is inherently path-invariant, so ECMP needed no design work. Zero PFC across all of it.</a:t>
             </a:r>
             <a:endParaRPr lang="en-US" dirty="0"/>
           </a:p>
@@ -1929,7 +1929,7 @@
           <a:p>
             <a:r>
               <a:rPr lang="en-US" dirty="0"/>
-              <a:t>So what does fairness buy on a workload operators care about? Collective communication: an allreduce step finishes when its slowest flow finishes, and the slowest flows are exactly the cross-pod multi-bottleneck ones stock HPCC starves. A 16-flow ring allreduce across five ECMP hash seeds: HPCC-FS cuts job completion time about 21 percent at every seed, and makes it placement-invariant. And a nuance we like being honest about: in this mix the short background flows also got three times faster — under winner-take-all, whether a short flow wins or loses is a placement lottery; max-min removes the lottery.</a:t>
+              <a:t>So what does fairness buy on a workload operators care about? Collective communication: an allreduce step finishes when its slowest flow finishes, and the slowest flows are exactly the cross-pod multi-bottleneck ones stock HPCC starves. A 16-flow ring allreduce across five ECMP hash seeds: RDMA-RCP cuts job completion time about 21 percent at every seed, and makes it placement-invariant. And a nuance we like being honest about: in this mix the short background flows also got three times faster — under winner-take-all, whether a short flow wins or loses is a placement lottery; max-min removes the lottery.</a:t>
             </a:r>
             <a:endParaRPr lang="en-US" dirty="0"/>
           </a:p>
@@ -2017,7 +2017,7 @@
           <a:p>
             <a:r>
               <a:rPr lang="en-US" dirty="0"/>
-              <a:t>Three defensibility checks. One: disabling the window is necessary, not a convenience — put it back and the penalty returns, growing with path length, because HPCC's window is sized for the NIC, not the path. Two: we did not tune RCP — the textbook defaults, and one-at-a-time sweeps barely move the result. Three: the cost question — on HPCC's home turf, a single-bottleneck incast, a moderate startup rate makes HPCC-FS match or beat HPCC's FCT while holding a quarter of the queue. On what we measured, the fairness mode is not a trade-off.</a:t>
+              <a:t>Three defensibility checks. One: disabling the window is necessary, not a convenience — put it back and the penalty returns, growing with path length, because HPCC's window is sized for the NIC, not the path. Two: we did not tune RCP — the textbook defaults, and one-at-a-time sweeps barely move the result. Three: the cost question — on HPCC's home turf, a single-bottleneck incast, a moderate startup rate makes RDMA-RCP match or beat HPCC's FCT while holding a quarter of the queue. On what we measured, the fairness mode is not a trade-off.</a:t>
             </a:r>
             <a:endParaRPr lang="en-US" dirty="0"/>
           </a:p>
@@ -2193,7 +2193,7 @@
           <a:p>
             <a:r>
               <a:rPr lang="en-US" dirty="0"/>
-              <a:t>To close: a real, robust fairness failure in the state of the art; evidence that the endpoint can't fix it because the endpoint can't see the flow count; and a deliberately minimal switch mode — one field, one scalar — that lands within about one percent of the max-min oracle with zero PFC, leaving stock HPCC byte-for-byte intact. One caveat we measured and report: on an unreserved shared queue the two modes do not each get a fair share, so HPCC-FS needs a reserved bandwidth share. Everything is in the artifact, including a full reproduction of the original HPCC baselines. Happy to take questions.</a:t>
+              <a:t>To close: a real, robust fairness failure in the state of the art; evidence that the endpoint can't fix it because the endpoint can't see the flow count; and a deliberately minimal switch mode — one field, one scalar — that lands within about one percent of the max-min oracle with zero PFC, leaving stock HPCC byte-for-byte intact. One caveat we measured and report: on an unreserved shared queue the two modes do not each get a fair share, and even a weighted-DRR reservation cannot fix it — both controllers still read port-global telemetry. Coexistence needs sliced signals or a separate fabric. Everything is in the artifact, including a full reproduction of the original HPCC baselines. Happy to take questions.</a:t>
             </a:r>
             <a:endParaRPr lang="en-US" dirty="0"/>
           </a:p>
@@ -2897,7 +2897,7 @@
           <a:p>
             <a:r>
               <a:rPr lang="en-US" dirty="0"/>
-              <a:t>Our first instinct — and probably yours — was to fix this at the sender, keeping HPCC's stateless-switch story intact. We built five variants spanning the design space: additive boosts, debiasing, decrease-side scaling, share-aware updates. Best case gets you 1.63; the target is 1.0. This is the paper's negative result, and it motivates everything after: why does every endpoint fix stall?</a:t>
+              <a:t>Our first instinct — and probably yours — was to fix this at the sender, keeping HPCC's stateless-switch story intact. We built five heuristic variants spanning the design space — best case 1.63, target 1.0 — and then the strongest possible sender design: a full mirror of the RCP recursion, run privately per hop from the same INT-visible inputs the switch would use. The mirror still fails: 1.56 even with synchronized starts, 1.65 or 0.81 under staggered arrival — the direction of unfairness set by arrival order — while the identical law at the switch holds 1.0. That is the next slide's story.</a:t>
             </a:r>
             <a:endParaRPr lang="en-US" dirty="0"/>
           </a:p>
@@ -2985,7 +2985,7 @@
           <a:p>
             <a:r>
               <a:rPr lang="en-US" dirty="0"/>
-              <a:t>Two reasons, and they compose. First, at equilibrium HPCC's multiplicative machinery goes idle — everyone just holds. Second, even if you wanted a strong corrective move, the fair share is C over N, and N — the flow count — simply is not in the INT signal. The only N-free sender mechanism is additive nudging, which we just showed is hopelessly slow. Conclusion: put the fair-share computation where N is implicitly visible — the link. That's a 20-year-old idea: RCP.</a:t>
+              <a:t>Two reasons. First, at eta-hold, HPCC's multiplicative machinery goes idle — everyone holds what they grabbed. Second — and this is the paper's sharpest experiment — the obstacle is NOT information. RCP's inputs are all sender-visible in INT, so we ran the strongest sender design: a private per-hop RCP mirror. Same law, same inputs, same gains. It still fails, and the direction of unfairness flips with arrival order — because multiplicative updates on private state preserve initial disagreement forever. Max-min is an agreement property: every flow must adopt one shared rate. A per-port register is the cheapest consistent shared reference. That is the placement result, and it is why RCP belongs in the switch.</a:t>
             </a:r>
             <a:endParaRPr lang="en-US" dirty="0"/>
           </a:p>
@@ -3733,7 +3733,7 @@
                 <a:ea typeface="Cambria" pitchFamily="34" charset="-122"/>
                 <a:cs typeface="Cambria" pitchFamily="34" charset="-120"/>
               </a:rPr>
-              <a:t>Multi-Bottleneck Fairness for</a:t>
+              <a:t>Multi-Bottleneck Fairness on RDMA Fabrics:</a:t>
             </a:r>
             <a:endParaRPr lang="en-US" sz="3300" dirty="0"/>
           </a:p>
@@ -3750,7 +3750,7 @@
                 <a:ea typeface="Cambria" pitchFamily="34" charset="-122"/>
                 <a:cs typeface="Cambria" pitchFamily="34" charset="-120"/>
               </a:rPr>
-              <a:t>High-Precision Congestion Control</a:t>
+              <a:t>An Empirical Study</a:t>
             </a:r>
             <a:endParaRPr lang="en-US" sz="3300" dirty="0"/>
           </a:p>
@@ -3789,7 +3789,7 @@
                 <a:ea typeface="Calibri" pitchFamily="34" charset="-122"/>
                 <a:cs typeface="Calibri" pitchFamily="34" charset="-120"/>
               </a:rPr>
-              <a:t>HPCC-FS — one fair-rate field, one scalar per switch port</a:t>
+              <a:t>RDMA-RCP — an RCP service mode over INT: one fair-rate field, one scalar per port</a:t>
             </a:r>
             <a:endParaRPr lang="en-US" sz="1700" dirty="0"/>
           </a:p>
@@ -4871,7 +4871,7 @@
                 <a:ea typeface="Calibri" pitchFamily="34" charset="-122"/>
                 <a:cs typeface="Calibri" pitchFamily="34" charset="-120"/>
               </a:rPr>
-              <a:t>HPCC-FS</a:t>
+              <a:t>RDMA-RCP</a:t>
             </a:r>
             <a:endParaRPr lang="en-US" sz="1100" dirty="0"/>
           </a:p>
@@ -5609,7 +5609,7 @@
       </p:sp>
       <p:pic>
         <p:nvPicPr>
-          <p:cNvPr id="4" name="Image 0" descr="/Users/tiffanyzhang/uno-hpcc/examples/hpcc/hpcc-fs/figures/fig_nsweep.png">    </p:cNvPr>
+          <p:cNvPr id="4" name="Image 0" descr="../figures/fig_nsweep.png">    </p:cNvPr>
           <p:cNvPicPr>
             <a:picLocks noChangeAspect="1"/>
           </p:cNvPicPr>
@@ -6037,7 +6037,7 @@
       </p:sp>
       <p:pic>
         <p:nvPicPr>
-          <p:cNvPr id="4" name="Image 0" descr="/Users/tiffanyzhang/uno-hpcc/examples/hpcc/hpcc-fs/figures/fig_robustness.png">    </p:cNvPr>
+          <p:cNvPr id="4" name="Image 0" descr="../figures/fig_robustness.png">    </p:cNvPr>
           <p:cNvPicPr>
             <a:picLocks noChangeAspect="1"/>
           </p:cNvPicPr>
@@ -6092,7 +6092,7 @@
                 <a:ea typeface="Calibri" pitchFamily="34" charset="-122"/>
                 <a:cs typeface="Calibri" pitchFamily="34" charset="-120"/>
               </a:rPr>
-              <a:t>six asymmetric-size / staggered-start variants at N = 4: HPCC-FS within 1.0 ± 0.012 (worst stock case 3.53× → 1.012×)</a:t>
+              <a:t>six asymmetric-size / staggered-start variants at N = 4: RDMA-RCP within 1.0 ± 0.012 (worst stock case 3.53× → 1.012×); start-jitter ensembles: stock 1.96–1.99×, RDMA-RCP 1.008–1.017×</a:t>
             </a:r>
             <a:endParaRPr lang="en-US" sz="1100" dirty="0"/>
           </a:p>
@@ -6279,7 +6279,7 @@
                           <a:ea typeface="Calibri" pitchFamily="34" charset="-122"/>
                           <a:cs typeface="Calibri" pitchFamily="34" charset="-120"/>
                         </a:rPr>
-                        <a:t>HPCC-FS</a:t>
+                        <a:t>RDMA-RCP</a:t>
                       </a:r>
                       <a:endParaRPr lang="en-US" sz="1200" dirty="0">
                         <a:latin typeface="Calibri" charset="0"/>
@@ -6986,7 +6986,7 @@
                 <a:ea typeface="Calibri" pitchFamily="34" charset="-122"/>
                 <a:cs typeface="Calibri" pitchFamily="34" charset="-120"/>
               </a:rPr>
-              <a:t>† oracle-normalized (removes ECMP placement luck). Across 5 hash seeds the raw ratio is placement-dominated; HPCC-FS ≤ stock at 4 of 5 seeds (the 5th is uncontended).</a:t>
+              <a:t>† oracle-normalized (removes ECMP placement luck). Across 5 hash seeds the raw ratio is placement-dominated; RDMA-RCP ≤ stock at 4 of 5 seeds (the 5th is uncontended).</a:t>
             </a:r>
             <a:endParaRPr lang="en-US" sz="1050" dirty="0"/>
           </a:p>
@@ -8124,7 +8124,7 @@
                 <a:ea typeface="Calibri" pitchFamily="34" charset="-122"/>
                 <a:cs typeface="Calibri" pitchFamily="34" charset="-120"/>
               </a:rPr>
-              <a:t>The mechanism is RCP; HPCC-FS is a mode, not a repair.  </a:t>
+              <a:t>The mechanism is RCP; RDMA-RCP is a mode, not a repair.  </a:t>
             </a:r>
             <a:pPr indent="0" marL="0">
               <a:buNone/>
@@ -8138,7 +8138,7 @@
                 <a:ea typeface="Calibri" pitchFamily="34" charset="-122"/>
                 <a:cs typeface="Calibri" pitchFamily="34" charset="-120"/>
               </a:rPr>
-              <a:t>We claim the diagnosis and the placement. HPCC-FS coexists with stock HPCC per traffic class; mixed classes sharing links are future work.</a:t>
+              <a:t>We claim the measurement and the placement. Coexistence needs sliced telemetry: even a 50/50 DWRR reservation cannot help a class whose controller reads port-global signals.</a:t>
             </a:r>
             <a:endParaRPr lang="en-US" sz="1400" dirty="0"/>
           </a:p>
@@ -8768,7 +8768,7 @@
                 <a:ea typeface="Calibri" pitchFamily="34" charset="-122"/>
                 <a:cs typeface="Calibri" pitchFamily="34" charset="-120"/>
               </a:rPr>
-              <a:t>Five sender-only fixes fail: at η-hold, no strong move exists without the flow count N.</a:t>
+              <a:t>Six sender-only designs fail — incl. a full RCP mirror. Max-min needs one shared reference rate.</a:t>
             </a:r>
             <a:endParaRPr lang="en-US" sz="1300" dirty="0"/>
           </a:p>
@@ -8829,7 +8829,7 @@
                 <a:ea typeface="Calibri" pitchFamily="34" charset="-122"/>
                 <a:cs typeface="Calibri" pitchFamily="34" charset="-120"/>
               </a:rPr>
-              <a:t>HPCC-FS</a:t>
+              <a:t>RDMA-RCP</a:t>
             </a:r>
             <a:endParaRPr lang="en-US" sz="1350" dirty="0"/>
           </a:p>
@@ -11149,7 +11149,7 @@
                 <a:ea typeface="Calibri" pitchFamily="34" charset="-122"/>
                 <a:cs typeface="Calibri" pitchFamily="34" charset="-120"/>
               </a:rPr>
-              <a:t>The 0.51× ‘advantage’ is corrupted control input, not fairness. HPCC-FS is immune: one field, any path length.</a:t>
+              <a:t>The 0.51× ‘advantage’ is corrupted control input, not fairness. RDMA-RCP is immune: one field, any path length.</a:t>
             </a:r>
             <a:endParaRPr lang="en-US" sz="1400" dirty="0"/>
           </a:p>
@@ -12621,7 +12621,7 @@
       </p:sp>
       <p:pic>
         <p:nvPicPr>
-          <p:cNvPr id="4" name="Image 0" descr="/Users/tiffanyzhang/uno-hpcc/examples/hpcc/hpcc-fs/figures/fig_topo_parking.png">    </p:cNvPr>
+          <p:cNvPr id="4" name="Image 0" descr="../figures/fig_topo_parking.png">    </p:cNvPr>
           <p:cNvPicPr>
             <a:picLocks noChangeAspect="1"/>
           </p:cNvPicPr>
@@ -13724,7 +13724,7 @@
                 <a:ea typeface="Calibri" pitchFamily="34" charset="-122"/>
                 <a:cs typeface="Calibri" pitchFamily="34" charset="-120"/>
               </a:rPr>
-              <a:t>Five sender-only fixes — none gets close</a:t>
+              <a:t>Six sender-only designs — none gets close</a:t>
             </a:r>
             <a:endParaRPr lang="en-US" sz="2700" dirty="0"/>
           </a:p>
@@ -15168,7 +15168,7 @@
                 <a:ea typeface="Calibri" pitchFamily="34" charset="-122"/>
                 <a:cs typeface="Calibri" pitchFamily="34" charset="-120"/>
               </a:rPr>
-              <a:t>Two structural reasons every sender-only fix stalls</a:t>
+              <a:t>Consistency, not information: what the RCP mirror proves</a:t>
             </a:r>
             <a:endParaRPr lang="en-US" sz="2700" dirty="0"/>
           </a:p>
@@ -15363,7 +15363,7 @@
                 <a:ea typeface="Calibri" pitchFamily="34" charset="-122"/>
                 <a:cs typeface="Calibri" pitchFamily="34" charset="-120"/>
               </a:rPr>
-              <a:t>2 · N is not observable</a:t>
+              <a:t>2 · Private estimates never agree</a:t>
             </a:r>
             <a:endParaRPr lang="en-US" sz="1600" dirty="0"/>
           </a:p>
@@ -15405,7 +15405,7 @@
                 <a:ea typeface="Calibri" pitchFamily="34" charset="-122"/>
                 <a:cs typeface="Calibri" pitchFamily="34" charset="-120"/>
               </a:rPr>
-              <a:t>Fair share is C / N. INT tells the sender C — never N, the link’s flow count.</a:t>
+              <a:t>RCP’s inputs (C, y, q) ARE in INT. A sender-side RCP mirror (mb_mode 6) still fails: 1.56× synced, 1.65×/0.81× staggered — direction set by arrival order.</a:t>
             </a:r>
             <a:endParaRPr lang="en-US" sz="1250" dirty="0"/>
           </a:p>
@@ -15422,7 +15422,7 @@
                 <a:ea typeface="Calibri" pitchFamily="34" charset="-122"/>
                 <a:cs typeface="Calibri" pitchFamily="34" charset="-120"/>
               </a:rPr>
-              <a:t>Without N there is no strong multiplicative move toward fair share — only slow AIMD nudging.</a:t>
+              <a:t>Multiplicative recursions on private state preserve initial disagreement. Max-min needs ONE shared reference rate.</a:t>
             </a:r>
             <a:endParaRPr lang="en-US" sz="1250" dirty="0"/>
           </a:p>
@@ -15490,7 +15490,7 @@
                 <a:ea typeface="Cambria" pitchFamily="34" charset="-122"/>
                 <a:cs typeface="Cambria" pitchFamily="34" charset="-120"/>
               </a:rPr>
-              <a:t>The information isn’t at the sender — so the fix can’t be either. It belongs at the link.</a:t>
+              <a:t>A per-port register is the cheapest shared reference every flow can agree on. That is why it belongs at the switch.</a:t>
             </a:r>
             <a:endParaRPr lang="en-US" sz="1650" dirty="0"/>
           </a:p>

</xml_diff>

<commit_message>
round-3 revision: absolute oracle metrics, FQ/header/idle/fan-in controls, saturating k=6, narrowed claim
- stress matrix reports per-flow oracle-relative FCT P[min,mean,max] + utilization
  (RCP P in 1.05-1.13 everywhere; utilization above stock in all scenarios)
- per-flow DRR + stock senders control: 1.970x - fair queueing alone cannot fix
  window-limited INT senders (run_round3.py)
- header-size control: ring coflow -18% with RCP padded to stock 42B layout
- idle-gap probe: frozen fair rate is benign (drain tail restores R to ~C)
- incast fan-in S=3..64: PFC-free through S=32; S=64 boundary reported honestly
- saturating k=6 fabric: 108 inter-pod flows, makespan -16.4%, PFC 0 (run_scale_saturate.py)
- ECMP seeds 5 -> 20 (RCP median 1.001 vs stock 1.06)
- claim narrowed to history-dependence of private explicit-rate state; deck + page updated
- both PDFs 10pp
</commit_message>
<xml_diff>
--- a/examples/hpcc/hpcc-fs/talk/ipccc2026-talk.pptx
+++ b/examples/hpcc/hpcc-fs/talk/ipccc2026-talk.pptx
@@ -1929,7 +1929,7 @@
           <a:p>
             <a:r>
               <a:rPr lang="en-US" dirty="0"/>
-              <a:t>So what does fairness buy on a workload operators care about? Collective communication: an allreduce step finishes when its slowest flow finishes, and the slowest flows are exactly the cross-pod multi-bottleneck ones stock HPCC starves. A 16-flow ring allreduce across five ECMP hash seeds: RDMA-RCP cuts job completion time about 21 percent at every seed, and makes it placement-invariant. And a nuance we like being honest about: in this mix the short background flows also got three times faster — under winner-take-all, whether a short flow wins or loses is a placement lottery; max-min removes the lottery.</a:t>
+              <a:t>So what does fairness buy on a workload operators care about? Collective communication: an allreduce step finishes when its slowest flow finishes, and the slowest flows are exactly the cross-pod multi-bottleneck ones stock HPCC starves. A 16-flow ring coflow — one phase of a ring allreduce — across five ECMP hash seeds: RDMA-RCP cuts completion time 18 to 23 percent at every seed tested, and 18 percent survives padding the INT header to stock size, so the gain is fairness, not header thinness. On a saturating k-equals-6 fabric with 108 inter-pod flows, makespan improves 16 percent. And the short background flows got three times faster — under near-winner-take-all dynamics, a short flow's fate is a placement lottery; max-min removes it.</a:t>
             </a:r>
             <a:endParaRPr lang="en-US" dirty="0"/>
           </a:p>
@@ -2985,7 +2985,7 @@
           <a:p>
             <a:r>
               <a:rPr lang="en-US" dirty="0"/>
-              <a:t>Two reasons. First, at eta-hold, HPCC's multiplicative machinery goes idle — everyone holds what they grabbed. Second — and this is the paper's sharpest experiment — the obstacle is NOT information. RCP's inputs are all sender-visible in INT, so we ran the strongest sender design: a private per-hop RCP mirror. Same law, same inputs, same gains. It still fails, and the direction of unfairness flips with arrival order — because multiplicative updates on private state preserve initial disagreement forever. Max-min is an agreement property: every flow must adopt one shared rate. A per-port register is the cheapest consistent shared reference. That is the placement result, and it is why RCP belongs in the switch.</a:t>
+              <a:t>Two reasons. First, at eta-hold, HPCC's multiplicative machinery goes idle — everyone holds what they grabbed. Second — and this is the paper's sharpest experiment — the obstacle is NOT information. RCP's inputs are all sender-visible in INT, so we ran the most direct sender design: a private per-hop RCP mirror. Same law, same inputs, same gains. It still fails, and the direction of unfairness flips with arrival order — because independently maintained rate state preserves arrival-history asymmetry forever, while a shared register erases it. Even per-flow fair queueing under stock senders leaves 1.97 times — a scheduler cannot give bandwidth a window-limited sender never offers. That is the placement result, scoped to explicit-rate state, and it is why RCP belongs in the switch.</a:t>
             </a:r>
             <a:endParaRPr lang="en-US" dirty="0"/>
           </a:p>
@@ -7096,7 +7096,7 @@
                 <a:ea typeface="Calibri" pitchFamily="34" charset="-122"/>
                 <a:cs typeface="Calibri" pitchFamily="34" charset="-120"/>
               </a:rPr>
-              <a:t>The job is gated by its slowest flow: −21% JCT</a:t>
+              <a:t>The job is gated by its slowest flow: −18–23% JCT</a:t>
             </a:r>
             <a:endParaRPr lang="en-US" sz="2700" dirty="0"/>
           </a:p>
@@ -7219,7 +7219,7 @@
                 <a:ea typeface="Cambria" pitchFamily="34" charset="-122"/>
                 <a:cs typeface="Cambria" pitchFamily="34" charset="-120"/>
               </a:rPr>
-              <a:t>−21%</a:t>
+              <a:t>−18–23%</a:t>
             </a:r>
             <a:endParaRPr lang="en-US" sz="1700" dirty="0"/>
           </a:p>
@@ -7236,7 +7236,7 @@
                 <a:ea typeface="Calibri" pitchFamily="34" charset="-122"/>
                 <a:cs typeface="Calibri" pitchFamily="34" charset="-120"/>
               </a:rPr>
-              <a:t>mean JCT — improves at every seed (+19.5…+22.7%)</a:t>
+              <a:t>JCT, every seed tested — −18% with the INT header padded to stock size</a:t>
             </a:r>
             <a:endParaRPr lang="en-US" sz="1700" dirty="0"/>
           </a:p>
@@ -8768,7 +8768,7 @@
                 <a:ea typeface="Calibri" pitchFamily="34" charset="-122"/>
                 <a:cs typeface="Calibri" pitchFamily="34" charset="-120"/>
               </a:rPr>
-              <a:t>Six sender-only designs fail — incl. a full RCP mirror. Max-min needs one shared reference rate.</a:t>
+              <a:t>Six sender-only designs fail — incl. a full RCP mirror — and per-flow FQ too. Private rate state keeps arrival history; a shared register erases it.</a:t>
             </a:r>
             <a:endParaRPr lang="en-US" sz="1300" dirty="0"/>
           </a:p>
@@ -8868,7 +8868,7 @@
                 <a:ea typeface="Calibri" pitchFamily="34" charset="-122"/>
                 <a:cs typeface="Calibri" pitchFamily="34" charset="-120"/>
               </a:rPr>
-              <a:t>A per-class mode alongside HPCC: 1.005×, zero PFC, −21% coflow JCT, stock path untouched.</a:t>
+              <a:t>A fabric/slice mode alongside HPCC: 1.005×, flows within 5–13% of oracle, zero PFC, −18–23% coflow JCT, stock path untouched.</a:t>
             </a:r>
             <a:endParaRPr lang="en-US" sz="1300" dirty="0"/>
           </a:p>
@@ -15168,7 +15168,7 @@
                 <a:ea typeface="Calibri" pitchFamily="34" charset="-122"/>
                 <a:cs typeface="Calibri" pitchFamily="34" charset="-120"/>
               </a:rPr>
-              <a:t>Consistency, not information: what the RCP mirror proves</a:t>
+              <a:t>Where the rate state lives: what the RCP mirror proves</a:t>
             </a:r>
             <a:endParaRPr lang="en-US" sz="2700" dirty="0"/>
           </a:p>
@@ -15422,7 +15422,7 @@
                 <a:ea typeface="Calibri" pitchFamily="34" charset="-122"/>
                 <a:cs typeface="Calibri" pitchFamily="34" charset="-120"/>
               </a:rPr>
-              <a:t>Multiplicative recursions on private state preserve initial disagreement. Max-min needs ONE shared reference rate.</a:t>
+              <a:t>Private copies of the explicit-rate recursion preserve arrival-history asymmetry; ONE shared per-link register erases it. Per-flow fair queueing under stock senders: still 1.97×.</a:t>
             </a:r>
             <a:endParaRPr lang="en-US" sz="1250" dirty="0"/>
           </a:p>
@@ -15490,7 +15490,7 @@
                 <a:ea typeface="Cambria" pitchFamily="34" charset="-122"/>
                 <a:cs typeface="Cambria" pitchFamily="34" charset="-120"/>
               </a:rPr>
-              <a:t>A per-port register is the cheapest shared reference every flow can agree on. That is why it belongs at the switch.</a:t>
+              <a:t>A shared per-port register carries the history a private copy cannot replicate. That is why it belongs at the switch.</a:t>
             </a:r>
             <a:endParaRPr lang="en-US" sz="1650" dirty="0"/>
           </a:p>

</xml_diff>

<commit_message>
round-4: decouple adopted-rate floor from cold-start (fs_min_rate); FQ ablations correct round-3 claim
- reviewer-caught design flaw: HandleAckFs clamped adopted rate to the 1G
  cold-start, making N <= C/1G a hard incast bound; S=64 PFC storm was
  floor-induced overload (2,045 pauses / 142 ms), not startup transient
- fs_min_rate knob (default 100 Mb/s): PFC 0 through S=128, rates reach
  182 Mb/s at S=64; ~2x stock FCT at S>=64 is the honest residual
- FQ ablations: windowless HPCC + per-flow DRR equalizes (0.997x) but at
  13.6x oracle FCT (equal-but-idle); windowed 1.97x; claim corrected to
  'scheduling enforces equality; the allocation needs a rate signal'
- k=6 saturating refreshed (42.9 -> 36.7 ms, -11% padded-header control);
  fairness suites reproduce exactly under the new floor
- algorithms disambiguate R_start vs R_floor; abstract carries the
  5-13% / 21-39% dual range; both PDFs 10pp
</commit_message>
<xml_diff>
--- a/examples/hpcc/hpcc-fs/talk/ipccc2026-talk.pptx
+++ b/examples/hpcc/hpcc-fs/talk/ipccc2026-talk.pptx
@@ -2985,7 +2985,7 @@
           <a:p>
             <a:r>
               <a:rPr lang="en-US" dirty="0"/>
-              <a:t>Two reasons. First, at eta-hold, HPCC's multiplicative machinery goes idle — everyone holds what they grabbed. Second — and this is the paper's sharpest experiment — the obstacle is NOT information. RCP's inputs are all sender-visible in INT, so we ran the most direct sender design: a private per-hop RCP mirror. Same law, same inputs, same gains. It still fails, and the direction of unfairness flips with arrival order — because independently maintained rate state preserves arrival-history asymmetry forever, while a shared register erases it. Even per-flow fair queueing under stock senders leaves 1.97 times — a scheduler cannot give bandwidth a window-limited sender never offers. That is the placement result, scoped to explicit-rate state, and it is why RCP belongs in the switch.</a:t>
+              <a:t>Two reasons. First, at eta-hold, HPCC's multiplicative machinery goes idle — everyone holds what they grabbed. Second — and this is the paper's sharpest experiment — the obstacle is NOT information. RCP's inputs are all sender-visible in INT, so we ran the most direct sender design: a private per-hop RCP mirror. Same law, same inputs, same gains. It still fails, and the direction of unfairness flips with arrival order — because independently maintained rate state preserves arrival-history asymmetry forever, while a shared register erases it. Per-flow fair queueing sharpens it: windowed senders leave 1.97 times; remove the window and DRR equalizes — but at thirteen times every flow's oracle completion time, equal but idle. Scheduling enforces equality; the max-min allocation — equal shares at full utilization — also needs a rate signal telling senders how much to offer. That is the corrected placement result, and it is why the rate belongs in the switch.</a:t>
             </a:r>
             <a:endParaRPr lang="en-US" dirty="0"/>
           </a:p>
@@ -8768,7 +8768,7 @@
                 <a:ea typeface="Calibri" pitchFamily="34" charset="-122"/>
                 <a:cs typeface="Calibri" pitchFamily="34" charset="-120"/>
               </a:rPr>
-              <a:t>Six sender-only designs fail — incl. a full RCP mirror — and per-flow FQ too. Private rate state keeps arrival history; a shared register erases it.</a:t>
+              <a:t>Six sender-only designs fail — incl. a full RCP mirror. Per-flow FQ equalizes only what senders offer: 1.97× windowed, equal-but-idle windowless.</a:t>
             </a:r>
             <a:endParaRPr lang="en-US" sz="1300" dirty="0"/>
           </a:p>
@@ -8868,7 +8868,7 @@
                 <a:ea typeface="Calibri" pitchFamily="34" charset="-122"/>
                 <a:cs typeface="Calibri" pitchFamily="34" charset="-120"/>
               </a:rPr>
-              <a:t>A fabric/slice mode alongside HPCC: 1.005×, flows within 5–13% of oracle, zero PFC, −18–23% coflow JCT, stock path untouched.</a:t>
+              <a:t>A fabric/slice mode alongside HPCC: 1.005×, flows within 5–13% of oracle (hetero cases), zero PFC, −18–23% coflow JCT, PFC-free to 128-way incast.</a:t>
             </a:r>
             <a:endParaRPr lang="en-US" sz="1300" dirty="0"/>
           </a:p>
@@ -15422,7 +15422,7 @@
                 <a:ea typeface="Calibri" pitchFamily="34" charset="-122"/>
                 <a:cs typeface="Calibri" pitchFamily="34" charset="-120"/>
               </a:rPr>
-              <a:t>Private copies of the explicit-rate recursion preserve arrival-history asymmetry; ONE shared per-link register erases it. Per-flow fair queueing under stock senders: still 1.97×.</a:t>
+              <a:t>Private copies of the explicit-rate recursion preserve arrival-history asymmetry; ONE shared per-link register erases it. Per-flow fair queueing: 1.97× windowed, equal-but-idle (13× oracle FCT) windowless.</a:t>
             </a:r>
             <a:endParaRPr lang="en-US" sz="1250" dirty="0"/>
           </a:p>

</xml_diff>